<commit_message>
Evidencias de ejecución embebidas en la presentación (reemplaza demo en vivo)
- 2 diapositivas nuevas de "Evidencia de ejecución" con capturas reales de consola:
  pipeline + KPIs, 22 pruebas pytest, y seguridad + RAG
- La slide del agente ahora apunta a la evidencia en vez de "demo en vivo"
- Deck: 11 -> 13 diapositivas

Co-Authored-By: Claude Opus 4.8 <noreply@anthropic.com>
</commit_message>
<xml_diff>
--- a/entrega/EFT_Presentacion_Defensa.pptx
+++ b/entrega/EFT_Presentacion_Defensa.pptx
@@ -16,6 +16,8 @@
     <p:sldId id="264" r:id="rId16"/>
     <p:sldId id="265" r:id="rId17"/>
     <p:sldId id="266" r:id="rId18"/>
+    <p:sldId id="267" r:id="rId19"/>
+    <p:sldId id="268" r:id="rId20"/>
   </p:sldIdLst>
   <p:sldSz cx="12191695" cy="6858000" type="screen4x3"/>
   <p:notesSz cx="6858000" cy="9144000"/>
@@ -582,7 +584,7 @@
           <a:lstStyle/>
           <a:p>
             <a:r>
-              <a:t>Cada mejora se fundamenta en un hallazgo de las métricas. Prioriza la desambiguación (mayor impacto en precisión). Conecta con sostenibilidad y escalabilidad. (~1 min)</a:t>
+              <a:t>Muestra que la observabilidad SIRVE: detectó un incidente automáticamente, identificó el cuello de botella y la causa raíz de los fallos (selección de herramienta y ambigüedad). Demuestra capacidad de análisis. (~1 min)</a:t>
             </a:r>
           </a:p>
         </p:txBody>
@@ -652,6 +654,146 @@
           <a:lstStyle/>
           <a:p>
             <a:r>
+              <a:t>Recorre los 5 controles y el marco normativo. Reflexión ética en tus palabras: privacidad, confirmación humana, riesgo de sesgo. Prepárate para preguntas de dilemas éticos. (~1 min)</a:t>
+            </a:r>
+          </a:p>
+        </p:txBody>
+      </p:sp>
+      <p:sp>
+        <p:nvSpPr>
+          <p:cNvPr id="4" name="Slide Number Placeholder 3"/>
+          <p:cNvSpPr>
+            <a:spLocks noGrp="1"/>
+          </p:cNvSpPr>
+          <p:nvPr>
+            <p:ph type="sldNum" idx="5" sz="quarter"/>
+          </p:nvPr>
+        </p:nvSpPr>
+        <p:spPr/>
+      </p:sp>
+    </p:spTree>
+  </p:cSld>
+  <p:clrMapOvr>
+    <a:masterClrMapping/>
+  </p:clrMapOvr>
+</p:notes>
+</file>
+
+<file path=ppt/notesSlides/notesSlide12.xml><?xml version="1.0" encoding="utf-8"?>
+<p:notes xmlns:a="http://schemas.openxmlformats.org/drawingml/2006/main" xmlns:p="http://schemas.openxmlformats.org/presentationml/2006/main" xmlns:r="http://schemas.openxmlformats.org/officeDocument/2006/relationships">
+  <p:cSld>
+    <p:spTree>
+      <p:nvGrpSpPr>
+        <p:cNvPr id="1" name=""/>
+        <p:cNvGrpSpPr/>
+        <p:nvPr/>
+      </p:nvGrpSpPr>
+      <p:grpSpPr>
+        <a:xfrm>
+          <a:off x="0" y="0"/>
+          <a:ext cx="0" cy="0"/>
+          <a:chOff x="0" y="0"/>
+          <a:chExt cx="0" cy="0"/>
+        </a:xfrm>
+      </p:grpSpPr>
+      <p:sp>
+        <p:nvSpPr>
+          <p:cNvPr id="2" name="Slide Image Placeholder 1"/>
+          <p:cNvSpPr>
+            <a:spLocks noGrp="1"/>
+          </p:cNvSpPr>
+          <p:nvPr>
+            <p:ph type="sldImg" idx="2"/>
+          </p:nvPr>
+        </p:nvSpPr>
+        <p:spPr/>
+      </p:sp>
+      <p:sp>
+        <p:nvSpPr>
+          <p:cNvPr id="3" name="Notes Placeholder 2"/>
+          <p:cNvSpPr>
+            <a:spLocks noGrp="1"/>
+          </p:cNvSpPr>
+          <p:nvPr>
+            <p:ph type="body" idx="3" sz="quarter"/>
+          </p:nvPr>
+        </p:nvSpPr>
+        <p:spPr/>
+        <p:txBody>
+          <a:bodyPr/>
+          <a:lstStyle/>
+          <a:p>
+            <a:r>
+              <a:t>Cada mejora se fundamenta en un hallazgo de las métricas. Prioriza la desambiguación (mayor impacto en precisión). Conecta con sostenibilidad y escalabilidad. (~1 min)</a:t>
+            </a:r>
+          </a:p>
+        </p:txBody>
+      </p:sp>
+      <p:sp>
+        <p:nvSpPr>
+          <p:cNvPr id="4" name="Slide Number Placeholder 3"/>
+          <p:cNvSpPr>
+            <a:spLocks noGrp="1"/>
+          </p:cNvSpPr>
+          <p:nvPr>
+            <p:ph type="sldNum" idx="5" sz="quarter"/>
+          </p:nvPr>
+        </p:nvSpPr>
+        <p:spPr/>
+      </p:sp>
+    </p:spTree>
+  </p:cSld>
+  <p:clrMapOvr>
+    <a:masterClrMapping/>
+  </p:clrMapOvr>
+</p:notes>
+</file>
+
+<file path=ppt/notesSlides/notesSlide13.xml><?xml version="1.0" encoding="utf-8"?>
+<p:notes xmlns:a="http://schemas.openxmlformats.org/drawingml/2006/main" xmlns:p="http://schemas.openxmlformats.org/presentationml/2006/main" xmlns:r="http://schemas.openxmlformats.org/officeDocument/2006/relationships">
+  <p:cSld>
+    <p:spTree>
+      <p:nvGrpSpPr>
+        <p:cNvPr id="1" name=""/>
+        <p:cNvGrpSpPr/>
+        <p:nvPr/>
+      </p:nvGrpSpPr>
+      <p:grpSpPr>
+        <a:xfrm>
+          <a:off x="0" y="0"/>
+          <a:ext cx="0" cy="0"/>
+          <a:chOff x="0" y="0"/>
+          <a:chExt cx="0" cy="0"/>
+        </a:xfrm>
+      </p:grpSpPr>
+      <p:sp>
+        <p:nvSpPr>
+          <p:cNvPr id="2" name="Slide Image Placeholder 1"/>
+          <p:cNvSpPr>
+            <a:spLocks noGrp="1"/>
+          </p:cNvSpPr>
+          <p:nvPr>
+            <p:ph type="sldImg" idx="2"/>
+          </p:nvPr>
+        </p:nvSpPr>
+        <p:spPr/>
+      </p:sp>
+      <p:sp>
+        <p:nvSpPr>
+          <p:cNvPr id="3" name="Notes Placeholder 2"/>
+          <p:cNvSpPr>
+            <a:spLocks noGrp="1"/>
+          </p:cNvSpPr>
+          <p:nvPr>
+            <p:ph type="body" idx="3" sz="quarter"/>
+          </p:nvPr>
+        </p:nvSpPr>
+        <p:spPr/>
+        <p:txBody>
+          <a:bodyPr/>
+          <a:lstStyle/>
+          <a:p>
+            <a:r>
               <a:t>Cierra con la idea fuerza: solución medible, segura y escalable. Invita a preguntas. Responde con evidencia y lenguaje técnico (IE13–IE15). (~30 s)</a:t>
             </a:r>
           </a:p>
@@ -932,7 +1074,7 @@
           <a:lstStyle/>
           <a:p>
             <a:r>
-              <a:t>Aquí ejecutas la DEMO real (ten el entorno listo). Muestra memoria (recuerda el saldo) y planificación (crédito multi-etapa). Si no hay API, usa el notebook. (~2 min)</a:t>
+              <a:t>Explica las capacidades del agente. En lugar de demo en vivo, muestro la evidencia de ejecución real en las 2 diapositivas siguientes (el sistema corre, las 22 pruebas pasan, y la seguridad + RAG funcionan). (~2 min)</a:t>
             </a:r>
           </a:p>
         </p:txBody>
@@ -1002,7 +1144,7 @@
           <a:lstStyle/>
           <a:p>
             <a:r>
-              <a:t>Explica que el RAG combina fuentes internas y externas (clave de la rúbrica). El ejemplo muestra recuperación de ambos orígenes. Menciona que en producción se usan embeddings densos. (~1 min)</a:t>
+              <a:t>Evidencia real: la ejecución del pipeline reporta los KPIs sobre 688 interacciones (precisión 85%) y las 22 pruebas automatizadas pasan (verde). Reproducible con el .bat de evidencia o 'python run_observability.py'.</a:t>
             </a:r>
           </a:p>
         </p:txBody>
@@ -1072,7 +1214,7 @@
           <a:lstStyle/>
           <a:p>
             <a:r>
-              <a:t>Presenta las métricas reales sobre 688 interacciones: precisión 85%, error 6.9%, p95 8.3s, bloqueo de injection 88%. El panel es el dashboard de monitoreo. (~1.5 min)</a:t>
+              <a:t>Evidencia real: la capa de seguridad enmascara el RUT y bloquea el prompt-injection; el pipeline RAG recupera combinando fuentes internas (banco) y externas (CMF, SERNAC, Ley 19.628). Estas capturas reemplazan la demo en vivo.</a:t>
             </a:r>
           </a:p>
         </p:txBody>
@@ -1142,7 +1284,7 @@
           <a:lstStyle/>
           <a:p>
             <a:r>
-              <a:t>Muestra que la observabilidad SIRVE: detectó un incidente automáticamente, identificó el cuello de botella y la causa raíz de los fallos (selección de herramienta y ambigüedad). Demuestra capacidad de análisis. (~1 min)</a:t>
+              <a:t>Explica que el RAG combina fuentes internas y externas (clave de la rúbrica). El ejemplo muestra recuperación de ambos orígenes. Menciona que en producción se usan embeddings densos. (~1 min)</a:t>
             </a:r>
           </a:p>
         </p:txBody>
@@ -1212,7 +1354,7 @@
           <a:lstStyle/>
           <a:p>
             <a:r>
-              <a:t>Recorre los 5 controles y el marco normativo. Reflexión ética en tus palabras: privacidad, confirmación humana, riesgo de sesgo. Prepárate para preguntas de dilemas éticos. (~1 min)</a:t>
+              <a:t>Presenta las métricas reales sobre 688 interacciones: precisión 85%, error 6.9%, p95 8.3s, bloqueo de injection 88%. El panel es el dashboard de monitoreo. (~1.5 min)</a:t>
             </a:r>
           </a:p>
         </p:txBody>
@@ -4567,7 +4709,7 @@
                 </a:solidFill>
                 <a:latin typeface="Georgia"/>
               </a:rPr>
-              <a:t>9</a:t>
+              <a:t>7</a:t>
             </a:r>
           </a:p>
         </p:txBody>
@@ -4606,23 +4748,236 @@
                 </a:solidFill>
                 <a:latin typeface="Georgia"/>
               </a:rPr>
-              <a:t>Mejoras propuestas</a:t>
-            </a:r>
-          </a:p>
-        </p:txBody>
-      </p:sp>
-      <p:sp>
-        <p:nvSpPr>
-          <p:cNvPr id="5" name="Oval 4"/>
+              <a:t>Trazabilidad — hallazgos clave</a:t>
+            </a:r>
+          </a:p>
+        </p:txBody>
+      </p:sp>
+      <p:pic>
+        <p:nvPicPr>
+          <p:cNvPr id="5" name="Picture 4" descr="03_serie_temporal_incidente.png"/>
+          <p:cNvPicPr>
+            <a:picLocks noChangeAspect="1"/>
+          </p:cNvPicPr>
+          <p:nvPr/>
+        </p:nvPicPr>
+        <p:blipFill>
+          <a:blip r:embed="rId2"/>
+          <a:stretch>
+            <a:fillRect/>
+          </a:stretch>
+        </p:blipFill>
+        <p:spPr>
+          <a:xfrm>
+            <a:off x="6126480" y="1554480"/>
+            <a:ext cx="5669280" cy="2684207"/>
+          </a:xfrm>
+          <a:prstGeom prst="rect">
+            <a:avLst/>
+          </a:prstGeom>
+        </p:spPr>
+      </p:pic>
+      <p:sp>
+        <p:nvSpPr>
+          <p:cNvPr id="6" name="TextBox 5"/>
+          <p:cNvSpPr txBox="1"/>
+          <p:nvPr/>
+        </p:nvSpPr>
+        <p:spPr>
+          <a:xfrm>
+            <a:off x="548640" y="1645920"/>
+            <a:ext cx="5394960" cy="4572000"/>
+          </a:xfrm>
+          <a:prstGeom prst="rect">
+            <a:avLst/>
+          </a:prstGeom>
+          <a:noFill/>
+        </p:spPr>
+        <p:txBody>
+          <a:bodyPr wrap="square" lIns="0" rIns="0" tIns="0" bIns="0">
+            <a:spAutoFit/>
+          </a:bodyPr>
+          <a:lstStyle/>
+          <a:p>
+            <a:pPr>
+              <a:lnSpc>
+                <a:spcPct val="105000"/>
+              </a:lnSpc>
+              <a:spcAft>
+                <a:spcPts val="1300"/>
+              </a:spcAft>
+            </a:pPr>
+            <a:r>
+              <a:rPr sz="1550" b="1">
+                <a:solidFill>
+                  <a:srgbClr val="E8A33D"/>
+                </a:solidFill>
+                <a:latin typeface="Calibri"/>
+              </a:rPr>
+              <a:t>▪  </a:t>
+            </a:r>
+            <a:r>
+              <a:rPr b="1" sz="1550">
+                <a:solidFill>
+                  <a:srgbClr val="222B35"/>
+                </a:solidFill>
+                <a:latin typeface="Calibri"/>
+              </a:rPr>
+              <a:t>Incidente detectado. </a:t>
+            </a:r>
+            <a:r>
+              <a:rPr sz="1550">
+                <a:solidFill>
+                  <a:srgbClr val="222B35"/>
+                </a:solidFill>
+                <a:latin typeface="Calibri"/>
+              </a:rPr>
+              <a:t>2025-06-11, latencia y error con z≈3 (auto-detección).</a:t>
+            </a:r>
+          </a:p>
+          <a:p>
+            <a:pPr>
+              <a:lnSpc>
+                <a:spcPct val="105000"/>
+              </a:lnSpc>
+              <a:spcAft>
+                <a:spcPts val="1300"/>
+              </a:spcAft>
+            </a:pPr>
+            <a:r>
+              <a:rPr sz="1550" b="1">
+                <a:solidFill>
+                  <a:srgbClr val="E8A33D"/>
+                </a:solidFill>
+                <a:latin typeface="Calibri"/>
+              </a:rPr>
+              <a:t>▪  </a:t>
+            </a:r>
+            <a:r>
+              <a:rPr b="1" sz="1550">
+                <a:solidFill>
+                  <a:srgbClr val="222B35"/>
+                </a:solidFill>
+                <a:latin typeface="Calibri"/>
+              </a:rPr>
+              <a:t>Cuello de botella. </a:t>
+            </a:r>
+            <a:r>
+              <a:rPr sz="1550">
+                <a:solidFill>
+                  <a:srgbClr val="222B35"/>
+                </a:solidFill>
+                <a:latin typeface="Calibri"/>
+              </a:rPr>
+              <a:t>Orquestación multi-agente, p95 ≈ 21 s.</a:t>
+            </a:r>
+          </a:p>
+          <a:p>
+            <a:pPr>
+              <a:lnSpc>
+                <a:spcPct val="105000"/>
+              </a:lnSpc>
+              <a:spcAft>
+                <a:spcPts val="1300"/>
+              </a:spcAft>
+            </a:pPr>
+            <a:r>
+              <a:rPr sz="1550" b="1">
+                <a:solidFill>
+                  <a:srgbClr val="E8A33D"/>
+                </a:solidFill>
+                <a:latin typeface="Calibri"/>
+              </a:rPr>
+              <a:t>▪  </a:t>
+            </a:r>
+            <a:r>
+              <a:rPr b="1" sz="1550">
+                <a:solidFill>
+                  <a:srgbClr val="222B35"/>
+                </a:solidFill>
+                <a:latin typeface="Calibri"/>
+              </a:rPr>
+              <a:t>Predictor de éxito. </a:t>
+            </a:r>
+            <a:r>
+              <a:rPr sz="1550">
+                <a:solidFill>
+                  <a:srgbClr val="222B35"/>
+                </a:solidFill>
+                <a:latin typeface="Calibri"/>
+              </a:rPr>
+              <a:t>Elegir la herramienta correcta: 95% vs 0%.</a:t>
+            </a:r>
+          </a:p>
+          <a:p>
+            <a:pPr>
+              <a:lnSpc>
+                <a:spcPct val="105000"/>
+              </a:lnSpc>
+              <a:spcAft>
+                <a:spcPts val="1300"/>
+              </a:spcAft>
+            </a:pPr>
+            <a:r>
+              <a:rPr sz="1550" b="1">
+                <a:solidFill>
+                  <a:srgbClr val="E8A33D"/>
+                </a:solidFill>
+                <a:latin typeface="Calibri"/>
+              </a:rPr>
+              <a:t>▪  </a:t>
+            </a:r>
+            <a:r>
+              <a:rPr b="1" sz="1550">
+                <a:solidFill>
+                  <a:srgbClr val="222B35"/>
+                </a:solidFill>
+                <a:latin typeface="Calibri"/>
+              </a:rPr>
+              <a:t>Ambigüedad. </a:t>
+            </a:r>
+            <a:r>
+              <a:rPr sz="1550">
+                <a:solidFill>
+                  <a:srgbClr val="222B35"/>
+                </a:solidFill>
+                <a:latin typeface="Calibri"/>
+              </a:rPr>
+              <a:t>Precisión cae 37 pp con entradas poco claras.</a:t>
+            </a:r>
+          </a:p>
+        </p:txBody>
+      </p:sp>
+    </p:spTree>
+  </p:cSld>
+  <p:clrMapOvr>
+    <a:masterClrMapping/>
+  </p:clrMapOvr>
+</p:sld>
+</file>
+
+<file path=ppt/slides/slide11.xml><?xml version="1.0" encoding="utf-8"?>
+<p:sld xmlns:a="http://schemas.openxmlformats.org/drawingml/2006/main" xmlns:p="http://schemas.openxmlformats.org/presentationml/2006/main" xmlns:r="http://schemas.openxmlformats.org/officeDocument/2006/relationships">
+  <p:cSld>
+    <p:spTree>
+      <p:nvGrpSpPr>
+        <p:cNvPr id="1" name=""/>
+        <p:cNvGrpSpPr/>
+        <p:nvPr/>
+      </p:nvGrpSpPr>
+      <p:grpSpPr/>
+      <p:sp>
+        <p:nvSpPr>
+          <p:cNvPr id="2" name="Rounded Rectangle 1"/>
           <p:cNvSpPr/>
           <p:nvPr/>
         </p:nvSpPr>
         <p:spPr>
           <a:xfrm>
-            <a:off x="548640" y="1645920"/>
+            <a:off x="548640" y="502920"/>
             <a:ext cx="457200" cy="457200"/>
           </a:xfrm>
-          <a:prstGeom prst="ellipse">
+          <a:prstGeom prst="roundRect">
             <a:avLst/>
           </a:prstGeom>
           <a:solidFill>
@@ -4657,13 +5012,13 @@
       </p:sp>
       <p:sp>
         <p:nvSpPr>
-          <p:cNvPr id="6" name="TextBox 5"/>
+          <p:cNvPr id="3" name="TextBox 2"/>
           <p:cNvSpPr txBox="1"/>
           <p:nvPr/>
         </p:nvSpPr>
         <p:spPr>
           <a:xfrm>
-            <a:off x="548640" y="1645920"/>
+            <a:off x="548640" y="502920"/>
             <a:ext cx="457200" cy="457200"/>
           </a:xfrm>
           <a:prstGeom prst="rect">
@@ -4683,27 +5038,27 @@
               </a:spcAft>
             </a:pPr>
             <a:r>
-              <a:rPr sz="1600" b="1" i="0">
+              <a:rPr sz="1800" b="1" i="0">
                 <a:solidFill>
                   <a:srgbClr val="0F2540"/>
                 </a:solidFill>
                 <a:latin typeface="Georgia"/>
               </a:rPr>
-              <a:t>1</a:t>
-            </a:r>
-          </a:p>
-        </p:txBody>
-      </p:sp>
-      <p:sp>
-        <p:nvSpPr>
-          <p:cNvPr id="7" name="TextBox 6"/>
+              <a:t>8</a:t>
+            </a:r>
+          </a:p>
+        </p:txBody>
+      </p:sp>
+      <p:sp>
+        <p:nvSpPr>
+          <p:cNvPr id="4" name="TextBox 3"/>
           <p:cNvSpPr txBox="1"/>
           <p:nvPr/>
         </p:nvSpPr>
         <p:spPr>
           <a:xfrm>
-            <a:off x="1188720" y="1618488"/>
-            <a:ext cx="10241280" cy="868680"/>
+            <a:off x="1143000" y="457200"/>
+            <a:ext cx="10424160" cy="640080"/>
           </a:xfrm>
           <a:prstGeom prst="rect">
             <a:avLst/>
@@ -4722,42 +5077,241 @@
               </a:spcAft>
             </a:pPr>
             <a:r>
-              <a:rPr sz="1600" b="1" i="0">
+              <a:rPr sz="3000" b="1" i="0">
                 <a:solidFill>
                   <a:srgbClr val="1F4E79"/>
                 </a:solidFill>
-                <a:latin typeface="Calibri"/>
-              </a:rPr>
-              <a:t>Desambiguación de intención.  </a:t>
-            </a:r>
-            <a:r>
-              <a:rPr sz="1500" b="0" i="0">
+                <a:latin typeface="Georgia"/>
+              </a:rPr>
+              <a:t>Seguridad y uso responsable</a:t>
+            </a:r>
+          </a:p>
+        </p:txBody>
+      </p:sp>
+      <p:sp>
+        <p:nvSpPr>
+          <p:cNvPr id="5" name="TextBox 4"/>
+          <p:cNvSpPr txBox="1"/>
+          <p:nvPr/>
+        </p:nvSpPr>
+        <p:spPr>
+          <a:xfrm>
+            <a:off x="548640" y="1600200"/>
+            <a:ext cx="5852160" cy="4572000"/>
+          </a:xfrm>
+          <a:prstGeom prst="rect">
+            <a:avLst/>
+          </a:prstGeom>
+          <a:noFill/>
+        </p:spPr>
+        <p:txBody>
+          <a:bodyPr wrap="square" lIns="0" rIns="0" tIns="0" bIns="0">
+            <a:spAutoFit/>
+          </a:bodyPr>
+          <a:lstStyle/>
+          <a:p>
+            <a:pPr>
+              <a:lnSpc>
+                <a:spcPct val="105000"/>
+              </a:lnSpc>
+              <a:spcAft>
+                <a:spcPts val="1100"/>
+              </a:spcAft>
+            </a:pPr>
+            <a:r>
+              <a:rPr sz="1550" b="1">
+                <a:solidFill>
+                  <a:srgbClr val="E8A33D"/>
+                </a:solidFill>
+                <a:latin typeface="Calibri"/>
+              </a:rPr>
+              <a:t>▪  </a:t>
+            </a:r>
+            <a:r>
+              <a:rPr b="1" sz="1550">
                 <a:solidFill>
                   <a:srgbClr val="222B35"/>
                 </a:solidFill>
                 <a:latin typeface="Calibri"/>
               </a:rPr>
-              <a:t>clarificar + few-shot de enrutamiento (mayor precisión)</a:t>
-            </a:r>
-          </a:p>
-        </p:txBody>
-      </p:sp>
-      <p:sp>
-        <p:nvSpPr>
-          <p:cNvPr id="8" name="Oval 7"/>
+              <a:t>Privacidad por diseño. </a:t>
+            </a:r>
+            <a:r>
+              <a:rPr sz="1550">
+                <a:solidFill>
+                  <a:srgbClr val="222B35"/>
+                </a:solidFill>
+                <a:latin typeface="Calibri"/>
+              </a:rPr>
+              <a:t>Enmascaramiento de PII (RUT, tarjeta) en logs y prompts.</a:t>
+            </a:r>
+          </a:p>
+          <a:p>
+            <a:pPr>
+              <a:lnSpc>
+                <a:spcPct val="105000"/>
+              </a:lnSpc>
+              <a:spcAft>
+                <a:spcPts val="1100"/>
+              </a:spcAft>
+            </a:pPr>
+            <a:r>
+              <a:rPr sz="1550" b="1">
+                <a:solidFill>
+                  <a:srgbClr val="E8A33D"/>
+                </a:solidFill>
+                <a:latin typeface="Calibri"/>
+              </a:rPr>
+              <a:t>▪  </a:t>
+            </a:r>
+            <a:r>
+              <a:rPr b="1" sz="1550">
+                <a:solidFill>
+                  <a:srgbClr val="222B35"/>
+                </a:solidFill>
+                <a:latin typeface="Calibri"/>
+              </a:rPr>
+              <a:t>Anti prompt-injection. </a:t>
+            </a:r>
+            <a:r>
+              <a:rPr sz="1550">
+                <a:solidFill>
+                  <a:srgbClr val="222B35"/>
+                </a:solidFill>
+                <a:latin typeface="Calibri"/>
+              </a:rPr>
+              <a:t>Bloqueo de manipulación del prompt (OWASP LLM01).</a:t>
+            </a:r>
+          </a:p>
+          <a:p>
+            <a:pPr>
+              <a:lnSpc>
+                <a:spcPct val="105000"/>
+              </a:lnSpc>
+              <a:spcAft>
+                <a:spcPts val="1100"/>
+              </a:spcAft>
+            </a:pPr>
+            <a:r>
+              <a:rPr sz="1550" b="1">
+                <a:solidFill>
+                  <a:srgbClr val="E8A33D"/>
+                </a:solidFill>
+                <a:latin typeface="Calibri"/>
+              </a:rPr>
+              <a:t>▪  </a:t>
+            </a:r>
+            <a:r>
+              <a:rPr b="1" sz="1550">
+                <a:solidFill>
+                  <a:srgbClr val="222B35"/>
+                </a:solidFill>
+                <a:latin typeface="Calibri"/>
+              </a:rPr>
+              <a:t>Rate-limit + validación. </a:t>
+            </a:r>
+            <a:r>
+              <a:rPr sz="1550">
+                <a:solidFill>
+                  <a:srgbClr val="222B35"/>
+                </a:solidFill>
+                <a:latin typeface="Calibri"/>
+              </a:rPr>
+              <a:t>Control de abuso y saneamiento de entrada.</a:t>
+            </a:r>
+          </a:p>
+          <a:p>
+            <a:pPr>
+              <a:lnSpc>
+                <a:spcPct val="105000"/>
+              </a:lnSpc>
+              <a:spcAft>
+                <a:spcPts val="1100"/>
+              </a:spcAft>
+            </a:pPr>
+            <a:r>
+              <a:rPr sz="1550" b="1">
+                <a:solidFill>
+                  <a:srgbClr val="E8A33D"/>
+                </a:solidFill>
+                <a:latin typeface="Calibri"/>
+              </a:rPr>
+              <a:t>▪  </a:t>
+            </a:r>
+            <a:r>
+              <a:rPr b="1" sz="1550">
+                <a:solidFill>
+                  <a:srgbClr val="222B35"/>
+                </a:solidFill>
+                <a:latin typeface="Calibri"/>
+              </a:rPr>
+              <a:t>Auditoría con hash. </a:t>
+            </a:r>
+            <a:r>
+              <a:rPr sz="1550">
+                <a:solidFill>
+                  <a:srgbClr val="222B35"/>
+                </a:solidFill>
+                <a:latin typeface="Calibri"/>
+              </a:rPr>
+              <a:t>Bitácora con integridad (no-repudio).</a:t>
+            </a:r>
+          </a:p>
+          <a:p>
+            <a:pPr>
+              <a:lnSpc>
+                <a:spcPct val="105000"/>
+              </a:lnSpc>
+              <a:spcAft>
+                <a:spcPts val="1100"/>
+              </a:spcAft>
+            </a:pPr>
+            <a:r>
+              <a:rPr sz="1550" b="1">
+                <a:solidFill>
+                  <a:srgbClr val="E8A33D"/>
+                </a:solidFill>
+                <a:latin typeface="Calibri"/>
+              </a:rPr>
+              <a:t>▪  </a:t>
+            </a:r>
+            <a:r>
+              <a:rPr b="1" sz="1550">
+                <a:solidFill>
+                  <a:srgbClr val="222B35"/>
+                </a:solidFill>
+                <a:latin typeface="Calibri"/>
+              </a:rPr>
+              <a:t>Confirmación humana. </a:t>
+            </a:r>
+            <a:r>
+              <a:rPr sz="1550">
+                <a:solidFill>
+                  <a:srgbClr val="222B35"/>
+                </a:solidFill>
+                <a:latin typeface="Calibri"/>
+              </a:rPr>
+              <a:t>Toda transferencia se valida explícitamente.</a:t>
+            </a:r>
+          </a:p>
+        </p:txBody>
+      </p:sp>
+      <p:sp>
+        <p:nvSpPr>
+          <p:cNvPr id="6" name="Rounded Rectangle 5"/>
           <p:cNvSpPr/>
           <p:nvPr/>
         </p:nvSpPr>
         <p:spPr>
           <a:xfrm>
-            <a:off x="548640" y="2578608"/>
-            <a:ext cx="457200" cy="457200"/>
-          </a:xfrm>
-          <a:prstGeom prst="ellipse">
+            <a:off x="6858000" y="1737360"/>
+            <a:ext cx="4754880" cy="3749039"/>
+          </a:xfrm>
+          <a:prstGeom prst="roundRect">
             <a:avLst/>
           </a:prstGeom>
           <a:solidFill>
-            <a:srgbClr val="E8A33D"/>
+            <a:srgbClr val="0F2540"/>
           </a:solidFill>
           <a:ln>
             <a:noFill/>
@@ -4788,14 +5342,14 @@
       </p:sp>
       <p:sp>
         <p:nvSpPr>
-          <p:cNvPr id="9" name="TextBox 8"/>
+          <p:cNvPr id="7" name="TextBox 6"/>
           <p:cNvSpPr txBox="1"/>
           <p:nvPr/>
         </p:nvSpPr>
         <p:spPr>
           <a:xfrm>
-            <a:off x="548640" y="2578608"/>
-            <a:ext cx="457200" cy="457200"/>
+            <a:off x="7178040" y="2011680"/>
+            <a:ext cx="4206240" cy="3291840"/>
           </a:xfrm>
           <a:prstGeom prst="rect">
             <a:avLst/>
@@ -4803,12 +5357,12 @@
           <a:noFill/>
         </p:spPr>
         <p:txBody>
-          <a:bodyPr wrap="square" anchor="ctr" lIns="0" rIns="0" tIns="0" bIns="0">
+          <a:bodyPr wrap="square" anchor="t" lIns="0" rIns="0" tIns="0" bIns="0">
             <a:spAutoFit/>
           </a:bodyPr>
           <a:lstStyle/>
           <a:p>
-            <a:pPr algn="ctr">
+            <a:pPr algn="l">
               <a:spcAft>
                 <a:spcPts val="200"/>
               </a:spcAft>
@@ -4816,36 +5370,13 @@
             <a:r>
               <a:rPr sz="1600" b="1" i="0">
                 <a:solidFill>
-                  <a:srgbClr val="0F2540"/>
+                  <a:srgbClr val="E8A33D"/>
                 </a:solidFill>
                 <a:latin typeface="Georgia"/>
               </a:rPr>
-              <a:t>2</a:t>
-            </a:r>
-          </a:p>
-        </p:txBody>
-      </p:sp>
-      <p:sp>
-        <p:nvSpPr>
-          <p:cNvPr id="10" name="TextBox 9"/>
-          <p:cNvSpPr txBox="1"/>
-          <p:nvPr/>
-        </p:nvSpPr>
-        <p:spPr>
-          <a:xfrm>
-            <a:off x="1188720" y="2551176"/>
-            <a:ext cx="10241280" cy="868680"/>
-          </a:xfrm>
-          <a:prstGeom prst="rect">
-            <a:avLst/>
-          </a:prstGeom>
-          <a:noFill/>
-        </p:spPr>
-        <p:txBody>
-          <a:bodyPr wrap="square" anchor="ctr" lIns="0" rIns="0" tIns="0" bIns="0">
-            <a:spAutoFit/>
-          </a:bodyPr>
-          <a:lstStyle/>
+              <a:t>Marco normativo</a:t>
+            </a:r>
+          </a:p>
           <a:p>
             <a:pPr algn="l">
               <a:spcAft>
@@ -4853,38 +5384,143 @@
               </a:spcAft>
             </a:pPr>
             <a:r>
-              <a:rPr sz="1600" b="1" i="0">
-                <a:solidFill>
-                  <a:srgbClr val="1F4E79"/>
-                </a:solidFill>
-                <a:latin typeface="Calibri"/>
-              </a:rPr>
-              <a:t>Optimizar multi-agente.  </a:t>
-            </a:r>
-            <a:r>
-              <a:rPr sz="1500" b="0" i="0">
-                <a:solidFill>
-                  <a:srgbClr val="222B35"/>
-                </a:solidFill>
-                <a:latin typeface="Calibri"/>
-              </a:rPr>
-              <a:t>paralelizar y cachear (menor latencia y costo)</a:t>
-            </a:r>
-          </a:p>
-        </p:txBody>
-      </p:sp>
-      <p:sp>
-        <p:nvSpPr>
-          <p:cNvPr id="11" name="Oval 10"/>
+              <a:rPr sz="600" b="0" i="0">
+                <a:solidFill>
+                  <a:srgbClr val="FFFFFF"/>
+                </a:solidFill>
+                <a:latin typeface="Calibri"/>
+              </a:rPr>
+              <a:t/>
+            </a:r>
+          </a:p>
+          <a:p>
+            <a:pPr algn="l">
+              <a:spcAft>
+                <a:spcPts val="200"/>
+              </a:spcAft>
+            </a:pPr>
+            <a:r>
+              <a:rPr sz="1400" b="0" i="0">
+                <a:solidFill>
+                  <a:srgbClr val="FFFFFF"/>
+                </a:solidFill>
+                <a:latin typeface="Calibri"/>
+              </a:rPr>
+              <a:t>Ley 19.628 — datos personales</a:t>
+            </a:r>
+          </a:p>
+          <a:p>
+            <a:pPr algn="l">
+              <a:spcAft>
+                <a:spcPts val="200"/>
+              </a:spcAft>
+            </a:pPr>
+            <a:r>
+              <a:rPr sz="1400" b="0" i="0">
+                <a:solidFill>
+                  <a:srgbClr val="FFFFFF"/>
+                </a:solidFill>
+                <a:latin typeface="Calibri"/>
+              </a:rPr>
+              <a:t>Normativa CMF — ciberseguridad</a:t>
+            </a:r>
+          </a:p>
+          <a:p>
+            <a:pPr algn="l">
+              <a:spcAft>
+                <a:spcPts val="200"/>
+              </a:spcAft>
+            </a:pPr>
+            <a:r>
+              <a:rPr sz="1400" b="0" i="0">
+                <a:solidFill>
+                  <a:srgbClr val="FFFFFF"/>
+                </a:solidFill>
+                <a:latin typeface="Calibri"/>
+              </a:rPr>
+              <a:t>OWASP Top 10 for LLM</a:t>
+            </a:r>
+          </a:p>
+          <a:p>
+            <a:pPr algn="l">
+              <a:spcAft>
+                <a:spcPts val="200"/>
+              </a:spcAft>
+            </a:pPr>
+            <a:r>
+              <a:rPr sz="800" b="0" i="0">
+                <a:solidFill>
+                  <a:srgbClr val="FFFFFF"/>
+                </a:solidFill>
+                <a:latin typeface="Calibri"/>
+              </a:rPr>
+              <a:t/>
+            </a:r>
+          </a:p>
+          <a:p>
+            <a:pPr algn="l">
+              <a:spcAft>
+                <a:spcPts val="200"/>
+              </a:spcAft>
+            </a:pPr>
+            <a:r>
+              <a:rPr sz="1300" b="0" i="1">
+                <a:solidFill>
+                  <a:srgbClr val="D6E4F0"/>
+                </a:solidFill>
+                <a:latin typeface="Calibri"/>
+              </a:rPr>
+              <a:t>Ética: transparencia, no maleficencia,</a:t>
+            </a:r>
+          </a:p>
+          <a:p>
+            <a:pPr algn="l">
+              <a:spcAft>
+                <a:spcPts val="200"/>
+              </a:spcAft>
+            </a:pPr>
+            <a:r>
+              <a:rPr sz="1300" b="0" i="1">
+                <a:solidFill>
+                  <a:srgbClr val="D6E4F0"/>
+                </a:solidFill>
+                <a:latin typeface="Calibri"/>
+              </a:rPr>
+              <a:t>equidad y supervisión humana.</a:t>
+            </a:r>
+          </a:p>
+        </p:txBody>
+      </p:sp>
+    </p:spTree>
+  </p:cSld>
+  <p:clrMapOvr>
+    <a:masterClrMapping/>
+  </p:clrMapOvr>
+</p:sld>
+</file>
+
+<file path=ppt/slides/slide12.xml><?xml version="1.0" encoding="utf-8"?>
+<p:sld xmlns:a="http://schemas.openxmlformats.org/drawingml/2006/main" xmlns:p="http://schemas.openxmlformats.org/presentationml/2006/main" xmlns:r="http://schemas.openxmlformats.org/officeDocument/2006/relationships">
+  <p:cSld>
+    <p:spTree>
+      <p:nvGrpSpPr>
+        <p:cNvPr id="1" name=""/>
+        <p:cNvGrpSpPr/>
+        <p:nvPr/>
+      </p:nvGrpSpPr>
+      <p:grpSpPr/>
+      <p:sp>
+        <p:nvSpPr>
+          <p:cNvPr id="2" name="Rounded Rectangle 1"/>
           <p:cNvSpPr/>
           <p:nvPr/>
         </p:nvSpPr>
         <p:spPr>
           <a:xfrm>
-            <a:off x="548640" y="3511296"/>
+            <a:off x="548640" y="502920"/>
             <a:ext cx="457200" cy="457200"/>
           </a:xfrm>
-          <a:prstGeom prst="ellipse">
+          <a:prstGeom prst="roundRect">
             <a:avLst/>
           </a:prstGeom>
           <a:solidFill>
@@ -4919,13 +5555,13 @@
       </p:sp>
       <p:sp>
         <p:nvSpPr>
-          <p:cNvPr id="12" name="TextBox 11"/>
+          <p:cNvPr id="3" name="TextBox 2"/>
           <p:cNvSpPr txBox="1"/>
           <p:nvPr/>
         </p:nvSpPr>
         <p:spPr>
           <a:xfrm>
-            <a:off x="548640" y="3511296"/>
+            <a:off x="548640" y="502920"/>
             <a:ext cx="457200" cy="457200"/>
           </a:xfrm>
           <a:prstGeom prst="rect">
@@ -4945,27 +5581,27 @@
               </a:spcAft>
             </a:pPr>
             <a:r>
-              <a:rPr sz="1600" b="1" i="0">
+              <a:rPr sz="1800" b="1" i="0">
                 <a:solidFill>
                   <a:srgbClr val="0F2540"/>
                 </a:solidFill>
                 <a:latin typeface="Georgia"/>
               </a:rPr>
-              <a:t>3</a:t>
-            </a:r>
-          </a:p>
-        </p:txBody>
-      </p:sp>
-      <p:sp>
-        <p:nvSpPr>
-          <p:cNvPr id="13" name="TextBox 12"/>
+              <a:t>9</a:t>
+            </a:r>
+          </a:p>
+        </p:txBody>
+      </p:sp>
+      <p:sp>
+        <p:nvSpPr>
+          <p:cNvPr id="4" name="TextBox 3"/>
           <p:cNvSpPr txBox="1"/>
           <p:nvPr/>
         </p:nvSpPr>
         <p:spPr>
           <a:xfrm>
-            <a:off x="1188720" y="3483864"/>
-            <a:ext cx="10241280" cy="868680"/>
+            <a:off x="1143000" y="457200"/>
+            <a:ext cx="10424160" cy="640080"/>
           </a:xfrm>
           <a:prstGeom prst="rect">
             <a:avLst/>
@@ -4984,35 +5620,26 @@
               </a:spcAft>
             </a:pPr>
             <a:r>
-              <a:rPr sz="1600" b="1" i="0">
+              <a:rPr sz="3000" b="1" i="0">
                 <a:solidFill>
                   <a:srgbClr val="1F4E79"/>
                 </a:solidFill>
-                <a:latin typeface="Calibri"/>
-              </a:rPr>
-              <a:t>Resiliencia.  </a:t>
-            </a:r>
-            <a:r>
-              <a:rPr sz="1500" b="0" i="0">
-                <a:solidFill>
-                  <a:srgbClr val="222B35"/>
-                </a:solidFill>
-                <a:latin typeface="Calibri"/>
-              </a:rPr>
-              <a:t>reintentos con backoff + modelo de respaldo</a:t>
-            </a:r>
-          </a:p>
-        </p:txBody>
-      </p:sp>
-      <p:sp>
-        <p:nvSpPr>
-          <p:cNvPr id="14" name="Oval 13"/>
+                <a:latin typeface="Georgia"/>
+              </a:rPr>
+              <a:t>Mejoras propuestas</a:t>
+            </a:r>
+          </a:p>
+        </p:txBody>
+      </p:sp>
+      <p:sp>
+        <p:nvSpPr>
+          <p:cNvPr id="5" name="Oval 4"/>
           <p:cNvSpPr/>
           <p:nvPr/>
         </p:nvSpPr>
         <p:spPr>
           <a:xfrm>
-            <a:off x="548640" y="4443984"/>
+            <a:off x="548640" y="1645920"/>
             <a:ext cx="457200" cy="457200"/>
           </a:xfrm>
           <a:prstGeom prst="ellipse">
@@ -5050,13 +5677,13 @@
       </p:sp>
       <p:sp>
         <p:nvSpPr>
-          <p:cNvPr id="15" name="TextBox 14"/>
+          <p:cNvPr id="6" name="TextBox 5"/>
           <p:cNvSpPr txBox="1"/>
           <p:nvPr/>
         </p:nvSpPr>
         <p:spPr>
           <a:xfrm>
-            <a:off x="548640" y="4443984"/>
+            <a:off x="548640" y="1645920"/>
             <a:ext cx="457200" cy="457200"/>
           </a:xfrm>
           <a:prstGeom prst="rect">
@@ -5082,20 +5709,20 @@
                 </a:solidFill>
                 <a:latin typeface="Georgia"/>
               </a:rPr>
-              <a:t>4</a:t>
-            </a:r>
-          </a:p>
-        </p:txBody>
-      </p:sp>
-      <p:sp>
-        <p:nvSpPr>
-          <p:cNvPr id="16" name="TextBox 15"/>
+              <a:t>1</a:t>
+            </a:r>
+          </a:p>
+        </p:txBody>
+      </p:sp>
+      <p:sp>
+        <p:nvSpPr>
+          <p:cNvPr id="7" name="TextBox 6"/>
           <p:cNvSpPr txBox="1"/>
           <p:nvPr/>
         </p:nvSpPr>
         <p:spPr>
           <a:xfrm>
-            <a:off x="1188720" y="4416552"/>
+            <a:off x="1188720" y="1618488"/>
             <a:ext cx="10241280" cy="868680"/>
           </a:xfrm>
           <a:prstGeom prst="rect">
@@ -5121,7 +5748,7 @@
                 </a:solidFill>
                 <a:latin typeface="Calibri"/>
               </a:rPr>
-              <a:t>Reforzar guardrail.  </a:t>
+              <a:t>Desambiguación de intención.  </a:t>
             </a:r>
             <a:r>
               <a:rPr sz="1500" b="0" i="0">
@@ -5130,20 +5757,20 @@
                 </a:solidFill>
                 <a:latin typeface="Calibri"/>
               </a:rPr>
-              <a:t>clasificador LLM + canary tokens (bloqueo →100%)</a:t>
-            </a:r>
-          </a:p>
-        </p:txBody>
-      </p:sp>
-      <p:sp>
-        <p:nvSpPr>
-          <p:cNvPr id="17" name="Oval 16"/>
+              <a:t>clarificar + few-shot de enrutamiento (mayor precisión)</a:t>
+            </a:r>
+          </a:p>
+        </p:txBody>
+      </p:sp>
+      <p:sp>
+        <p:nvSpPr>
+          <p:cNvPr id="8" name="Oval 7"/>
           <p:cNvSpPr/>
           <p:nvPr/>
         </p:nvSpPr>
         <p:spPr>
           <a:xfrm>
-            <a:off x="548640" y="5376672"/>
+            <a:off x="548640" y="2578608"/>
             <a:ext cx="457200" cy="457200"/>
           </a:xfrm>
           <a:prstGeom prst="ellipse">
@@ -5181,6 +5808,399 @@
       </p:sp>
       <p:sp>
         <p:nvSpPr>
+          <p:cNvPr id="9" name="TextBox 8"/>
+          <p:cNvSpPr txBox="1"/>
+          <p:nvPr/>
+        </p:nvSpPr>
+        <p:spPr>
+          <a:xfrm>
+            <a:off x="548640" y="2578608"/>
+            <a:ext cx="457200" cy="457200"/>
+          </a:xfrm>
+          <a:prstGeom prst="rect">
+            <a:avLst/>
+          </a:prstGeom>
+          <a:noFill/>
+        </p:spPr>
+        <p:txBody>
+          <a:bodyPr wrap="square" anchor="ctr" lIns="0" rIns="0" tIns="0" bIns="0">
+            <a:spAutoFit/>
+          </a:bodyPr>
+          <a:lstStyle/>
+          <a:p>
+            <a:pPr algn="ctr">
+              <a:spcAft>
+                <a:spcPts val="200"/>
+              </a:spcAft>
+            </a:pPr>
+            <a:r>
+              <a:rPr sz="1600" b="1" i="0">
+                <a:solidFill>
+                  <a:srgbClr val="0F2540"/>
+                </a:solidFill>
+                <a:latin typeface="Georgia"/>
+              </a:rPr>
+              <a:t>2</a:t>
+            </a:r>
+          </a:p>
+        </p:txBody>
+      </p:sp>
+      <p:sp>
+        <p:nvSpPr>
+          <p:cNvPr id="10" name="TextBox 9"/>
+          <p:cNvSpPr txBox="1"/>
+          <p:nvPr/>
+        </p:nvSpPr>
+        <p:spPr>
+          <a:xfrm>
+            <a:off x="1188720" y="2551176"/>
+            <a:ext cx="10241280" cy="868680"/>
+          </a:xfrm>
+          <a:prstGeom prst="rect">
+            <a:avLst/>
+          </a:prstGeom>
+          <a:noFill/>
+        </p:spPr>
+        <p:txBody>
+          <a:bodyPr wrap="square" anchor="ctr" lIns="0" rIns="0" tIns="0" bIns="0">
+            <a:spAutoFit/>
+          </a:bodyPr>
+          <a:lstStyle/>
+          <a:p>
+            <a:pPr algn="l">
+              <a:spcAft>
+                <a:spcPts val="200"/>
+              </a:spcAft>
+            </a:pPr>
+            <a:r>
+              <a:rPr sz="1600" b="1" i="0">
+                <a:solidFill>
+                  <a:srgbClr val="1F4E79"/>
+                </a:solidFill>
+                <a:latin typeface="Calibri"/>
+              </a:rPr>
+              <a:t>Optimizar multi-agente.  </a:t>
+            </a:r>
+            <a:r>
+              <a:rPr sz="1500" b="0" i="0">
+                <a:solidFill>
+                  <a:srgbClr val="222B35"/>
+                </a:solidFill>
+                <a:latin typeface="Calibri"/>
+              </a:rPr>
+              <a:t>paralelizar y cachear (menor latencia y costo)</a:t>
+            </a:r>
+          </a:p>
+        </p:txBody>
+      </p:sp>
+      <p:sp>
+        <p:nvSpPr>
+          <p:cNvPr id="11" name="Oval 10"/>
+          <p:cNvSpPr/>
+          <p:nvPr/>
+        </p:nvSpPr>
+        <p:spPr>
+          <a:xfrm>
+            <a:off x="548640" y="3511296"/>
+            <a:ext cx="457200" cy="457200"/>
+          </a:xfrm>
+          <a:prstGeom prst="ellipse">
+            <a:avLst/>
+          </a:prstGeom>
+          <a:solidFill>
+            <a:srgbClr val="E8A33D"/>
+          </a:solidFill>
+          <a:ln>
+            <a:noFill/>
+          </a:ln>
+          <a:effectLst/>
+        </p:spPr>
+        <p:style>
+          <a:lnRef idx="1">
+            <a:schemeClr val="accent1"/>
+          </a:lnRef>
+          <a:fillRef idx="3">
+            <a:schemeClr val="accent1"/>
+          </a:fillRef>
+          <a:effectRef idx="2">
+            <a:schemeClr val="accent1"/>
+          </a:effectRef>
+          <a:fontRef idx="minor">
+            <a:schemeClr val="lt1"/>
+          </a:fontRef>
+        </p:style>
+        <p:txBody>
+          <a:bodyPr rtlCol="0" anchor="ctr"/>
+          <a:lstStyle/>
+          <a:p>
+            <a:pPr algn="ctr"/>
+          </a:p>
+        </p:txBody>
+      </p:sp>
+      <p:sp>
+        <p:nvSpPr>
+          <p:cNvPr id="12" name="TextBox 11"/>
+          <p:cNvSpPr txBox="1"/>
+          <p:nvPr/>
+        </p:nvSpPr>
+        <p:spPr>
+          <a:xfrm>
+            <a:off x="548640" y="3511296"/>
+            <a:ext cx="457200" cy="457200"/>
+          </a:xfrm>
+          <a:prstGeom prst="rect">
+            <a:avLst/>
+          </a:prstGeom>
+          <a:noFill/>
+        </p:spPr>
+        <p:txBody>
+          <a:bodyPr wrap="square" anchor="ctr" lIns="0" rIns="0" tIns="0" bIns="0">
+            <a:spAutoFit/>
+          </a:bodyPr>
+          <a:lstStyle/>
+          <a:p>
+            <a:pPr algn="ctr">
+              <a:spcAft>
+                <a:spcPts val="200"/>
+              </a:spcAft>
+            </a:pPr>
+            <a:r>
+              <a:rPr sz="1600" b="1" i="0">
+                <a:solidFill>
+                  <a:srgbClr val="0F2540"/>
+                </a:solidFill>
+                <a:latin typeface="Georgia"/>
+              </a:rPr>
+              <a:t>3</a:t>
+            </a:r>
+          </a:p>
+        </p:txBody>
+      </p:sp>
+      <p:sp>
+        <p:nvSpPr>
+          <p:cNvPr id="13" name="TextBox 12"/>
+          <p:cNvSpPr txBox="1"/>
+          <p:nvPr/>
+        </p:nvSpPr>
+        <p:spPr>
+          <a:xfrm>
+            <a:off x="1188720" y="3483864"/>
+            <a:ext cx="10241280" cy="868680"/>
+          </a:xfrm>
+          <a:prstGeom prst="rect">
+            <a:avLst/>
+          </a:prstGeom>
+          <a:noFill/>
+        </p:spPr>
+        <p:txBody>
+          <a:bodyPr wrap="square" anchor="ctr" lIns="0" rIns="0" tIns="0" bIns="0">
+            <a:spAutoFit/>
+          </a:bodyPr>
+          <a:lstStyle/>
+          <a:p>
+            <a:pPr algn="l">
+              <a:spcAft>
+                <a:spcPts val="200"/>
+              </a:spcAft>
+            </a:pPr>
+            <a:r>
+              <a:rPr sz="1600" b="1" i="0">
+                <a:solidFill>
+                  <a:srgbClr val="1F4E79"/>
+                </a:solidFill>
+                <a:latin typeface="Calibri"/>
+              </a:rPr>
+              <a:t>Resiliencia.  </a:t>
+            </a:r>
+            <a:r>
+              <a:rPr sz="1500" b="0" i="0">
+                <a:solidFill>
+                  <a:srgbClr val="222B35"/>
+                </a:solidFill>
+                <a:latin typeface="Calibri"/>
+              </a:rPr>
+              <a:t>reintentos con backoff + modelo de respaldo</a:t>
+            </a:r>
+          </a:p>
+        </p:txBody>
+      </p:sp>
+      <p:sp>
+        <p:nvSpPr>
+          <p:cNvPr id="14" name="Oval 13"/>
+          <p:cNvSpPr/>
+          <p:nvPr/>
+        </p:nvSpPr>
+        <p:spPr>
+          <a:xfrm>
+            <a:off x="548640" y="4443984"/>
+            <a:ext cx="457200" cy="457200"/>
+          </a:xfrm>
+          <a:prstGeom prst="ellipse">
+            <a:avLst/>
+          </a:prstGeom>
+          <a:solidFill>
+            <a:srgbClr val="E8A33D"/>
+          </a:solidFill>
+          <a:ln>
+            <a:noFill/>
+          </a:ln>
+          <a:effectLst/>
+        </p:spPr>
+        <p:style>
+          <a:lnRef idx="1">
+            <a:schemeClr val="accent1"/>
+          </a:lnRef>
+          <a:fillRef idx="3">
+            <a:schemeClr val="accent1"/>
+          </a:fillRef>
+          <a:effectRef idx="2">
+            <a:schemeClr val="accent1"/>
+          </a:effectRef>
+          <a:fontRef idx="minor">
+            <a:schemeClr val="lt1"/>
+          </a:fontRef>
+        </p:style>
+        <p:txBody>
+          <a:bodyPr rtlCol="0" anchor="ctr"/>
+          <a:lstStyle/>
+          <a:p>
+            <a:pPr algn="ctr"/>
+          </a:p>
+        </p:txBody>
+      </p:sp>
+      <p:sp>
+        <p:nvSpPr>
+          <p:cNvPr id="15" name="TextBox 14"/>
+          <p:cNvSpPr txBox="1"/>
+          <p:nvPr/>
+        </p:nvSpPr>
+        <p:spPr>
+          <a:xfrm>
+            <a:off x="548640" y="4443984"/>
+            <a:ext cx="457200" cy="457200"/>
+          </a:xfrm>
+          <a:prstGeom prst="rect">
+            <a:avLst/>
+          </a:prstGeom>
+          <a:noFill/>
+        </p:spPr>
+        <p:txBody>
+          <a:bodyPr wrap="square" anchor="ctr" lIns="0" rIns="0" tIns="0" bIns="0">
+            <a:spAutoFit/>
+          </a:bodyPr>
+          <a:lstStyle/>
+          <a:p>
+            <a:pPr algn="ctr">
+              <a:spcAft>
+                <a:spcPts val="200"/>
+              </a:spcAft>
+            </a:pPr>
+            <a:r>
+              <a:rPr sz="1600" b="1" i="0">
+                <a:solidFill>
+                  <a:srgbClr val="0F2540"/>
+                </a:solidFill>
+                <a:latin typeface="Georgia"/>
+              </a:rPr>
+              <a:t>4</a:t>
+            </a:r>
+          </a:p>
+        </p:txBody>
+      </p:sp>
+      <p:sp>
+        <p:nvSpPr>
+          <p:cNvPr id="16" name="TextBox 15"/>
+          <p:cNvSpPr txBox="1"/>
+          <p:nvPr/>
+        </p:nvSpPr>
+        <p:spPr>
+          <a:xfrm>
+            <a:off x="1188720" y="4416552"/>
+            <a:ext cx="10241280" cy="868680"/>
+          </a:xfrm>
+          <a:prstGeom prst="rect">
+            <a:avLst/>
+          </a:prstGeom>
+          <a:noFill/>
+        </p:spPr>
+        <p:txBody>
+          <a:bodyPr wrap="square" anchor="ctr" lIns="0" rIns="0" tIns="0" bIns="0">
+            <a:spAutoFit/>
+          </a:bodyPr>
+          <a:lstStyle/>
+          <a:p>
+            <a:pPr algn="l">
+              <a:spcAft>
+                <a:spcPts val="200"/>
+              </a:spcAft>
+            </a:pPr>
+            <a:r>
+              <a:rPr sz="1600" b="1" i="0">
+                <a:solidFill>
+                  <a:srgbClr val="1F4E79"/>
+                </a:solidFill>
+                <a:latin typeface="Calibri"/>
+              </a:rPr>
+              <a:t>Reforzar guardrail.  </a:t>
+            </a:r>
+            <a:r>
+              <a:rPr sz="1500" b="0" i="0">
+                <a:solidFill>
+                  <a:srgbClr val="222B35"/>
+                </a:solidFill>
+                <a:latin typeface="Calibri"/>
+              </a:rPr>
+              <a:t>clasificador LLM + canary tokens (bloqueo →100%)</a:t>
+            </a:r>
+          </a:p>
+        </p:txBody>
+      </p:sp>
+      <p:sp>
+        <p:nvSpPr>
+          <p:cNvPr id="17" name="Oval 16"/>
+          <p:cNvSpPr/>
+          <p:nvPr/>
+        </p:nvSpPr>
+        <p:spPr>
+          <a:xfrm>
+            <a:off x="548640" y="5376672"/>
+            <a:ext cx="457200" cy="457200"/>
+          </a:xfrm>
+          <a:prstGeom prst="ellipse">
+            <a:avLst/>
+          </a:prstGeom>
+          <a:solidFill>
+            <a:srgbClr val="E8A33D"/>
+          </a:solidFill>
+          <a:ln>
+            <a:noFill/>
+          </a:ln>
+          <a:effectLst/>
+        </p:spPr>
+        <p:style>
+          <a:lnRef idx="1">
+            <a:schemeClr val="accent1"/>
+          </a:lnRef>
+          <a:fillRef idx="3">
+            <a:schemeClr val="accent1"/>
+          </a:fillRef>
+          <a:effectRef idx="2">
+            <a:schemeClr val="accent1"/>
+          </a:effectRef>
+          <a:fontRef idx="minor">
+            <a:schemeClr val="lt1"/>
+          </a:fontRef>
+        </p:style>
+        <p:txBody>
+          <a:bodyPr rtlCol="0" anchor="ctr"/>
+          <a:lstStyle/>
+          <a:p>
+            <a:pPr algn="ctr"/>
+          </a:p>
+        </p:txBody>
+      </p:sp>
+      <p:sp>
+        <p:nvSpPr>
           <p:cNvPr id="18" name="TextBox 17"/>
           <p:cNvSpPr txBox="1"/>
           <p:nvPr/>
@@ -5274,7 +6294,7 @@
 </p:sld>
 </file>
 
-<file path=ppt/slides/slide11.xml><?xml version="1.0" encoding="utf-8"?>
+<file path=ppt/slides/slide13.xml><?xml version="1.0" encoding="utf-8"?>
 <p:sld xmlns:a="http://schemas.openxmlformats.org/drawingml/2006/main" xmlns:p="http://schemas.openxmlformats.org/presentationml/2006/main" xmlns:r="http://schemas.openxmlformats.org/officeDocument/2006/relationships">
   <p:cSld>
     <p:spTree>
@@ -7782,7 +8802,7 @@
                 </a:solidFill>
                 <a:latin typeface="Calibri"/>
               </a:rPr>
-              <a:t>DEMO EN VIVO:  </a:t>
+              <a:t>EVIDENCIA DE EJECUCIÓN:  </a:t>
             </a:r>
             <a:r>
               <a:rPr sz="1400" b="0" i="0">
@@ -7791,7 +8811,7 @@
                 </a:solidFill>
                 <a:latin typeface="Calibri"/>
               </a:rPr>
-              <a:t>consulta de saldo con RUT → simulación de crédito multi-etapa → dashboard de métricas.</a:t>
+              <a:t>capturas reales de la corrida en las 2 diapositivas siguientes (pipeline, 22 pruebas, seguridad y RAG).</a:t>
             </a:r>
           </a:p>
         </p:txBody>
@@ -7892,7 +8912,7 @@
                 </a:solidFill>
                 <a:latin typeface="Georgia"/>
               </a:rPr>
-              <a:t>5</a:t>
+              <a:t>E</a:t>
             </a:r>
           </a:p>
         </p:txBody>
@@ -7931,377 +8951,59 @@
                 </a:solidFill>
                 <a:latin typeface="Georgia"/>
               </a:rPr>
-              <a:t>Diseño LLM + RAG</a:t>
-            </a:r>
-          </a:p>
-        </p:txBody>
-      </p:sp>
-      <p:sp>
-        <p:nvSpPr>
-          <p:cNvPr id="5" name="TextBox 4"/>
-          <p:cNvSpPr txBox="1"/>
+              <a:t>Evidencia de ejecución — pipeline y pruebas</a:t>
+            </a:r>
+          </a:p>
+        </p:txBody>
+      </p:sp>
+      <p:pic>
+        <p:nvPicPr>
+          <p:cNvPr id="5" name="Picture 4" descr="ev_01_pipeline.png"/>
+          <p:cNvPicPr>
+            <a:picLocks noChangeAspect="1"/>
+          </p:cNvPicPr>
           <p:nvPr/>
-        </p:nvSpPr>
-        <p:spPr>
-          <a:xfrm>
-            <a:off x="548640" y="1554480"/>
-            <a:ext cx="5943600" cy="4114800"/>
+        </p:nvPicPr>
+        <p:blipFill>
+          <a:blip r:embed="rId2"/>
+          <a:stretch>
+            <a:fillRect/>
+          </a:stretch>
+        </p:blipFill>
+        <p:spPr>
+          <a:xfrm>
+            <a:off x="2651760" y="1371600"/>
+            <a:ext cx="6858000" cy="2133795"/>
           </a:xfrm>
           <a:prstGeom prst="rect">
             <a:avLst/>
           </a:prstGeom>
-          <a:noFill/>
-        </p:spPr>
-        <p:txBody>
-          <a:bodyPr wrap="square" lIns="0" rIns="0" tIns="0" bIns="0">
-            <a:spAutoFit/>
-          </a:bodyPr>
-          <a:lstStyle/>
-          <a:p>
-            <a:pPr>
-              <a:lnSpc>
-                <a:spcPct val="105000"/>
-              </a:lnSpc>
-              <a:spcAft>
-                <a:spcPts val="1200"/>
-              </a:spcAft>
-            </a:pPr>
-            <a:r>
-              <a:rPr sz="1600" b="1">
-                <a:solidFill>
-                  <a:srgbClr val="E8A33D"/>
-                </a:solidFill>
-                <a:latin typeface="Calibri"/>
-              </a:rPr>
-              <a:t>▪  </a:t>
-            </a:r>
-            <a:r>
-              <a:rPr b="1" sz="1600">
-                <a:solidFill>
-                  <a:srgbClr val="222B35"/>
-                </a:solidFill>
-                <a:latin typeface="Calibri"/>
-              </a:rPr>
-              <a:t>Prompts. </a:t>
-            </a:r>
-            <a:r>
-              <a:rPr sz="1600">
-                <a:solidFill>
-                  <a:srgbClr val="222B35"/>
-                </a:solidFill>
-                <a:latin typeface="Calibri"/>
-              </a:rPr>
-              <a:t>System prompt con rol y reglas + few-shot + chain-of-thought.</a:t>
-            </a:r>
-          </a:p>
-          <a:p>
-            <a:pPr>
-              <a:lnSpc>
-                <a:spcPct val="105000"/>
-              </a:lnSpc>
-              <a:spcAft>
-                <a:spcPts val="1200"/>
-              </a:spcAft>
-            </a:pPr>
-            <a:r>
-              <a:rPr sz="1600" b="1">
-                <a:solidFill>
-                  <a:srgbClr val="E8A33D"/>
-                </a:solidFill>
-                <a:latin typeface="Calibri"/>
-              </a:rPr>
-              <a:t>▪  </a:t>
-            </a:r>
-            <a:r>
-              <a:rPr b="1" sz="1600">
-                <a:solidFill>
-                  <a:srgbClr val="222B35"/>
-                </a:solidFill>
-                <a:latin typeface="Calibri"/>
-              </a:rPr>
-              <a:t>RAG. </a:t>
-            </a:r>
-            <a:r>
-              <a:rPr sz="1600">
-                <a:solidFill>
-                  <a:srgbClr val="222B35"/>
-                </a:solidFill>
-                <a:latin typeface="Calibri"/>
-              </a:rPr>
-              <a:t>Chunking → TF-IDF → recuperación top-k para fundamentar respuestas.</a:t>
-            </a:r>
-          </a:p>
-          <a:p>
-            <a:pPr>
-              <a:lnSpc>
-                <a:spcPct val="105000"/>
-              </a:lnSpc>
-              <a:spcAft>
-                <a:spcPts val="1200"/>
-              </a:spcAft>
-            </a:pPr>
-            <a:r>
-              <a:rPr sz="1600" b="1">
-                <a:solidFill>
-                  <a:srgbClr val="E8A33D"/>
-                </a:solidFill>
-                <a:latin typeface="Calibri"/>
-              </a:rPr>
-              <a:t>▪  </a:t>
-            </a:r>
-            <a:r>
-              <a:rPr b="1" sz="1600">
-                <a:solidFill>
-                  <a:srgbClr val="222B35"/>
-                </a:solidFill>
-                <a:latin typeface="Calibri"/>
-              </a:rPr>
-              <a:t>Fuentes internas. </a:t>
-            </a:r>
-            <a:r>
-              <a:rPr sz="1600">
-                <a:solidFill>
-                  <a:srgbClr val="222B35"/>
-                </a:solidFill>
-                <a:latin typeface="Calibri"/>
-              </a:rPr>
-              <a:t>Productos y políticas del banco.</a:t>
-            </a:r>
-          </a:p>
-          <a:p>
-            <a:pPr>
-              <a:lnSpc>
-                <a:spcPct val="105000"/>
-              </a:lnSpc>
-              <a:spcAft>
-                <a:spcPts val="1200"/>
-              </a:spcAft>
-            </a:pPr>
-            <a:r>
-              <a:rPr sz="1600" b="1">
-                <a:solidFill>
-                  <a:srgbClr val="E8A33D"/>
-                </a:solidFill>
-                <a:latin typeface="Calibri"/>
-              </a:rPr>
-              <a:t>▪  </a:t>
-            </a:r>
-            <a:r>
-              <a:rPr b="1" sz="1600">
-                <a:solidFill>
-                  <a:srgbClr val="222B35"/>
-                </a:solidFill>
-                <a:latin typeface="Calibri"/>
-              </a:rPr>
-              <a:t>Fuentes externas. </a:t>
-            </a:r>
-            <a:r>
-              <a:rPr sz="1600">
-                <a:solidFill>
-                  <a:srgbClr val="222B35"/>
-                </a:solidFill>
-                <a:latin typeface="Calibri"/>
-              </a:rPr>
-              <a:t>Normativa CMF, SERNAC y Ley 19.628.</a:t>
-            </a:r>
-          </a:p>
-        </p:txBody>
-      </p:sp>
-      <p:sp>
-        <p:nvSpPr>
-          <p:cNvPr id="6" name="Rounded Rectangle 5"/>
-          <p:cNvSpPr/>
+        </p:spPr>
+      </p:pic>
+      <p:pic>
+        <p:nvPicPr>
+          <p:cNvPr id="6" name="Picture 5" descr="ev_02_pruebas.png"/>
+          <p:cNvPicPr>
+            <a:picLocks noChangeAspect="1"/>
+          </p:cNvPicPr>
           <p:nvPr/>
-        </p:nvSpPr>
-        <p:spPr>
-          <a:xfrm>
-            <a:off x="6858000" y="1737360"/>
-            <a:ext cx="4754880" cy="3840480"/>
-          </a:xfrm>
-          <a:prstGeom prst="roundRect">
-            <a:avLst/>
-          </a:prstGeom>
-          <a:solidFill>
-            <a:srgbClr val="D6E4F0"/>
-          </a:solidFill>
-          <a:ln>
-            <a:noFill/>
-          </a:ln>
-          <a:effectLst/>
-        </p:spPr>
-        <p:style>
-          <a:lnRef idx="1">
-            <a:schemeClr val="accent1"/>
-          </a:lnRef>
-          <a:fillRef idx="3">
-            <a:schemeClr val="accent1"/>
-          </a:fillRef>
-          <a:effectRef idx="2">
-            <a:schemeClr val="accent1"/>
-          </a:effectRef>
-          <a:fontRef idx="minor">
-            <a:schemeClr val="lt1"/>
-          </a:fontRef>
-        </p:style>
-        <p:txBody>
-          <a:bodyPr rtlCol="0" anchor="ctr"/>
-          <a:lstStyle/>
-          <a:p>
-            <a:pPr algn="ctr"/>
-          </a:p>
-        </p:txBody>
-      </p:sp>
-      <p:sp>
-        <p:nvSpPr>
-          <p:cNvPr id="7" name="TextBox 6"/>
-          <p:cNvSpPr txBox="1"/>
-          <p:nvPr/>
-        </p:nvSpPr>
-        <p:spPr>
-          <a:xfrm>
-            <a:off x="7132320" y="1965960"/>
-            <a:ext cx="4206240" cy="3474720"/>
+        </p:nvPicPr>
+        <p:blipFill>
+          <a:blip r:embed="rId3"/>
+          <a:stretch>
+            <a:fillRect/>
+          </a:stretch>
+        </p:blipFill>
+        <p:spPr>
+          <a:xfrm>
+            <a:off x="2651760" y="3615123"/>
+            <a:ext cx="6858000" cy="3371923"/>
           </a:xfrm>
           <a:prstGeom prst="rect">
             <a:avLst/>
           </a:prstGeom>
-          <a:noFill/>
-        </p:spPr>
-        <p:txBody>
-          <a:bodyPr wrap="square" anchor="t" lIns="0" rIns="0" tIns="0" bIns="0">
-            <a:spAutoFit/>
-          </a:bodyPr>
-          <a:lstStyle/>
-          <a:p>
-            <a:pPr algn="l">
-              <a:spcAft>
-                <a:spcPts val="200"/>
-              </a:spcAft>
-            </a:pPr>
-            <a:r>
-              <a:rPr sz="1600" b="1" i="0">
-                <a:solidFill>
-                  <a:srgbClr val="1F4E79"/>
-                </a:solidFill>
-                <a:latin typeface="Georgia"/>
-              </a:rPr>
-              <a:t>Recuperación combinada</a:t>
-            </a:r>
-          </a:p>
-          <a:p>
-            <a:pPr algn="l">
-              <a:spcAft>
-                <a:spcPts val="200"/>
-              </a:spcAft>
-            </a:pPr>
-            <a:r>
-              <a:rPr sz="1200" b="0" i="1">
-                <a:solidFill>
-                  <a:srgbClr val="5A5A5A"/>
-                </a:solidFill>
-                <a:latin typeface="Calibri"/>
-              </a:rPr>
-              <a:t>Consulta: tasa de crédito + deber de información</a:t>
-            </a:r>
-          </a:p>
-          <a:p>
-            <a:pPr algn="l">
-              <a:spcAft>
-                <a:spcPts val="200"/>
-              </a:spcAft>
-            </a:pPr>
-            <a:r>
-              <a:rPr sz="600" b="0" i="0">
-                <a:solidFill>
-                  <a:srgbClr val="5A5A5A"/>
-                </a:solidFill>
-                <a:latin typeface="Calibri"/>
-              </a:rPr>
-              <a:t/>
-            </a:r>
-          </a:p>
-          <a:p>
-            <a:pPr algn="l">
-              <a:spcAft>
-                <a:spcPts val="200"/>
-              </a:spcAft>
-            </a:pPr>
-            <a:r>
-              <a:rPr sz="1300" b="0" i="0">
-                <a:solidFill>
-                  <a:srgbClr val="222B35"/>
-                </a:solidFill>
-                <a:latin typeface="Calibri"/>
-              </a:rPr>
-              <a:t>● interna — Catálogo de productos</a:t>
-            </a:r>
-          </a:p>
-          <a:p>
-            <a:pPr algn="l">
-              <a:spcAft>
-                <a:spcPts val="200"/>
-              </a:spcAft>
-            </a:pPr>
-            <a:r>
-              <a:rPr sz="1300" b="0" i="0">
-                <a:solidFill>
-                  <a:srgbClr val="222B35"/>
-                </a:solidFill>
-                <a:latin typeface="Calibri"/>
-              </a:rPr>
-              <a:t>● externa — CMF (información al cliente)</a:t>
-            </a:r>
-          </a:p>
-          <a:p>
-            <a:pPr algn="l">
-              <a:spcAft>
-                <a:spcPts val="200"/>
-              </a:spcAft>
-            </a:pPr>
-            <a:r>
-              <a:rPr sz="1300" b="0" i="0">
-                <a:solidFill>
-                  <a:srgbClr val="222B35"/>
-                </a:solidFill>
-                <a:latin typeface="Calibri"/>
-              </a:rPr>
-              <a:t>● interna — Política de crédito</a:t>
-            </a:r>
-          </a:p>
-          <a:p>
-            <a:pPr algn="l">
-              <a:spcAft>
-                <a:spcPts val="200"/>
-              </a:spcAft>
-            </a:pPr>
-            <a:r>
-              <a:rPr sz="600" b="0" i="0">
-                <a:solidFill>
-                  <a:srgbClr val="5A5A5A"/>
-                </a:solidFill>
-                <a:latin typeface="Calibri"/>
-              </a:rPr>
-              <a:t/>
-            </a:r>
-          </a:p>
-          <a:p>
-            <a:pPr algn="l">
-              <a:spcAft>
-                <a:spcPts val="200"/>
-              </a:spcAft>
-            </a:pPr>
-            <a:r>
-              <a:rPr sz="1200" b="1" i="0">
-                <a:solidFill>
-                  <a:srgbClr val="2E7D32"/>
-                </a:solidFill>
-                <a:latin typeface="Calibri"/>
-              </a:rPr>
-              <a:t>→ combina ambos orígenes en una sola respuesta</a:t>
-            </a:r>
-          </a:p>
-        </p:txBody>
-      </p:sp>
+        </p:spPr>
+      </p:pic>
     </p:spTree>
   </p:cSld>
   <p:clrMapOvr>
@@ -8398,7 +9100,7 @@
                 </a:solidFill>
                 <a:latin typeface="Georgia"/>
               </a:rPr>
-              <a:t>6</a:t>
+              <a:t>E</a:t>
             </a:r>
           </a:p>
         </p:txBody>
@@ -8437,410 +9139,14 @@
                 </a:solidFill>
                 <a:latin typeface="Georgia"/>
               </a:rPr>
-              <a:t>Observabilidad — resultados</a:t>
-            </a:r>
-          </a:p>
-        </p:txBody>
-      </p:sp>
-      <p:sp>
-        <p:nvSpPr>
-          <p:cNvPr id="5" name="Rounded Rectangle 4"/>
-          <p:cNvSpPr/>
-          <p:nvPr/>
-        </p:nvSpPr>
-        <p:spPr>
-          <a:xfrm>
-            <a:off x="548640" y="1508760"/>
-            <a:ext cx="2651760" cy="1371600"/>
-          </a:xfrm>
-          <a:prstGeom prst="roundRect">
-            <a:avLst/>
-          </a:prstGeom>
-          <a:noFill/>
-          <a:ln w="15875">
-            <a:solidFill>
-              <a:srgbClr val="2E7D32"/>
-            </a:solidFill>
-          </a:ln>
-          <a:effectLst/>
-        </p:spPr>
-        <p:style>
-          <a:lnRef idx="1">
-            <a:schemeClr val="accent1"/>
-          </a:lnRef>
-          <a:fillRef idx="3">
-            <a:schemeClr val="accent1"/>
-          </a:fillRef>
-          <a:effectRef idx="2">
-            <a:schemeClr val="accent1"/>
-          </a:effectRef>
-          <a:fontRef idx="minor">
-            <a:schemeClr val="lt1"/>
-          </a:fontRef>
-        </p:style>
-        <p:txBody>
-          <a:bodyPr rtlCol="0" anchor="ctr"/>
-          <a:lstStyle/>
-          <a:p>
-            <a:pPr algn="ctr"/>
-          </a:p>
-        </p:txBody>
-      </p:sp>
-      <p:sp>
-        <p:nvSpPr>
-          <p:cNvPr id="6" name="TextBox 5"/>
-          <p:cNvSpPr txBox="1"/>
-          <p:nvPr/>
-        </p:nvSpPr>
-        <p:spPr>
-          <a:xfrm>
-            <a:off x="548640" y="1572768"/>
-            <a:ext cx="2651760" cy="1280160"/>
-          </a:xfrm>
-          <a:prstGeom prst="rect">
-            <a:avLst/>
-          </a:prstGeom>
-          <a:noFill/>
-        </p:spPr>
-        <p:txBody>
-          <a:bodyPr wrap="square" anchor="ctr" lIns="0" rIns="0" tIns="0" bIns="0">
-            <a:spAutoFit/>
-          </a:bodyPr>
-          <a:lstStyle/>
-          <a:p>
-            <a:pPr algn="ctr">
-              <a:spcAft>
-                <a:spcPts val="200"/>
-              </a:spcAft>
-            </a:pPr>
-            <a:r>
-              <a:rPr sz="3400" b="1" i="0">
-                <a:solidFill>
-                  <a:srgbClr val="2E7D32"/>
-                </a:solidFill>
-                <a:latin typeface="Georgia"/>
-              </a:rPr>
-              <a:t>85%</a:t>
-            </a:r>
-          </a:p>
-          <a:p>
-            <a:pPr algn="ctr">
-              <a:spcAft>
-                <a:spcPts val="200"/>
-              </a:spcAft>
-            </a:pPr>
-            <a:r>
-              <a:rPr sz="1200" b="0" i="0">
-                <a:solidFill>
-                  <a:srgbClr val="5A5A5A"/>
-                </a:solidFill>
-                <a:latin typeface="Calibri"/>
-              </a:rPr>
-              <a:t>Precisión</a:t>
-            </a:r>
-          </a:p>
-        </p:txBody>
-      </p:sp>
-      <p:sp>
-        <p:nvSpPr>
-          <p:cNvPr id="7" name="Rounded Rectangle 6"/>
-          <p:cNvSpPr/>
-          <p:nvPr/>
-        </p:nvSpPr>
-        <p:spPr>
-          <a:xfrm>
-            <a:off x="3319272" y="1508760"/>
-            <a:ext cx="2651760" cy="1371600"/>
-          </a:xfrm>
-          <a:prstGeom prst="roundRect">
-            <a:avLst/>
-          </a:prstGeom>
-          <a:noFill/>
-          <a:ln w="15875">
-            <a:solidFill>
-              <a:srgbClr val="E8A33D"/>
-            </a:solidFill>
-          </a:ln>
-          <a:effectLst/>
-        </p:spPr>
-        <p:style>
-          <a:lnRef idx="1">
-            <a:schemeClr val="accent1"/>
-          </a:lnRef>
-          <a:fillRef idx="3">
-            <a:schemeClr val="accent1"/>
-          </a:fillRef>
-          <a:effectRef idx="2">
-            <a:schemeClr val="accent1"/>
-          </a:effectRef>
-          <a:fontRef idx="minor">
-            <a:schemeClr val="lt1"/>
-          </a:fontRef>
-        </p:style>
-        <p:txBody>
-          <a:bodyPr rtlCol="0" anchor="ctr"/>
-          <a:lstStyle/>
-          <a:p>
-            <a:pPr algn="ctr"/>
-          </a:p>
-        </p:txBody>
-      </p:sp>
-      <p:sp>
-        <p:nvSpPr>
-          <p:cNvPr id="8" name="TextBox 7"/>
-          <p:cNvSpPr txBox="1"/>
-          <p:nvPr/>
-        </p:nvSpPr>
-        <p:spPr>
-          <a:xfrm>
-            <a:off x="3319272" y="1572768"/>
-            <a:ext cx="2651760" cy="1280160"/>
-          </a:xfrm>
-          <a:prstGeom prst="rect">
-            <a:avLst/>
-          </a:prstGeom>
-          <a:noFill/>
-        </p:spPr>
-        <p:txBody>
-          <a:bodyPr wrap="square" anchor="ctr" lIns="0" rIns="0" tIns="0" bIns="0">
-            <a:spAutoFit/>
-          </a:bodyPr>
-          <a:lstStyle/>
-          <a:p>
-            <a:pPr algn="ctr">
-              <a:spcAft>
-                <a:spcPts val="200"/>
-              </a:spcAft>
-            </a:pPr>
-            <a:r>
-              <a:rPr sz="3400" b="1" i="0">
-                <a:solidFill>
-                  <a:srgbClr val="E8A33D"/>
-                </a:solidFill>
-                <a:latin typeface="Georgia"/>
-              </a:rPr>
-              <a:t>6.9%</a:t>
-            </a:r>
-          </a:p>
-          <a:p>
-            <a:pPr algn="ctr">
-              <a:spcAft>
-                <a:spcPts val="200"/>
-              </a:spcAft>
-            </a:pPr>
-            <a:r>
-              <a:rPr sz="1200" b="0" i="0">
-                <a:solidFill>
-                  <a:srgbClr val="5A5A5A"/>
-                </a:solidFill>
-                <a:latin typeface="Calibri"/>
-              </a:rPr>
-              <a:t>Tasa de error</a:t>
-            </a:r>
-          </a:p>
-        </p:txBody>
-      </p:sp>
-      <p:sp>
-        <p:nvSpPr>
-          <p:cNvPr id="9" name="Rounded Rectangle 8"/>
-          <p:cNvSpPr/>
-          <p:nvPr/>
-        </p:nvSpPr>
-        <p:spPr>
-          <a:xfrm>
-            <a:off x="6089904" y="1508760"/>
-            <a:ext cx="2651760" cy="1371600"/>
-          </a:xfrm>
-          <a:prstGeom prst="roundRect">
-            <a:avLst/>
-          </a:prstGeom>
-          <a:noFill/>
-          <a:ln w="15875">
-            <a:solidFill>
-              <a:srgbClr val="1F4E79"/>
-            </a:solidFill>
-          </a:ln>
-          <a:effectLst/>
-        </p:spPr>
-        <p:style>
-          <a:lnRef idx="1">
-            <a:schemeClr val="accent1"/>
-          </a:lnRef>
-          <a:fillRef idx="3">
-            <a:schemeClr val="accent1"/>
-          </a:fillRef>
-          <a:effectRef idx="2">
-            <a:schemeClr val="accent1"/>
-          </a:effectRef>
-          <a:fontRef idx="minor">
-            <a:schemeClr val="lt1"/>
-          </a:fontRef>
-        </p:style>
-        <p:txBody>
-          <a:bodyPr rtlCol="0" anchor="ctr"/>
-          <a:lstStyle/>
-          <a:p>
-            <a:pPr algn="ctr"/>
-          </a:p>
-        </p:txBody>
-      </p:sp>
-      <p:sp>
-        <p:nvSpPr>
-          <p:cNvPr id="10" name="TextBox 9"/>
-          <p:cNvSpPr txBox="1"/>
-          <p:nvPr/>
-        </p:nvSpPr>
-        <p:spPr>
-          <a:xfrm>
-            <a:off x="6089904" y="1572768"/>
-            <a:ext cx="2651760" cy="1280160"/>
-          </a:xfrm>
-          <a:prstGeom prst="rect">
-            <a:avLst/>
-          </a:prstGeom>
-          <a:noFill/>
-        </p:spPr>
-        <p:txBody>
-          <a:bodyPr wrap="square" anchor="ctr" lIns="0" rIns="0" tIns="0" bIns="0">
-            <a:spAutoFit/>
-          </a:bodyPr>
-          <a:lstStyle/>
-          <a:p>
-            <a:pPr algn="ctr">
-              <a:spcAft>
-                <a:spcPts val="200"/>
-              </a:spcAft>
-            </a:pPr>
-            <a:r>
-              <a:rPr sz="3400" b="1" i="0">
-                <a:solidFill>
-                  <a:srgbClr val="1F4E79"/>
-                </a:solidFill>
-                <a:latin typeface="Georgia"/>
-              </a:rPr>
-              <a:t>8.3s</a:t>
-            </a:r>
-          </a:p>
-          <a:p>
-            <a:pPr algn="ctr">
-              <a:spcAft>
-                <a:spcPts val="200"/>
-              </a:spcAft>
-            </a:pPr>
-            <a:r>
-              <a:rPr sz="1200" b="0" i="0">
-                <a:solidFill>
-                  <a:srgbClr val="5A5A5A"/>
-                </a:solidFill>
-                <a:latin typeface="Calibri"/>
-              </a:rPr>
-              <a:t>Latencia p95</a:t>
-            </a:r>
-          </a:p>
-        </p:txBody>
-      </p:sp>
-      <p:sp>
-        <p:nvSpPr>
-          <p:cNvPr id="11" name="Rounded Rectangle 10"/>
-          <p:cNvSpPr/>
-          <p:nvPr/>
-        </p:nvSpPr>
-        <p:spPr>
-          <a:xfrm>
-            <a:off x="8860536" y="1508760"/>
-            <a:ext cx="2651760" cy="1371600"/>
-          </a:xfrm>
-          <a:prstGeom prst="roundRect">
-            <a:avLst/>
-          </a:prstGeom>
-          <a:noFill/>
-          <a:ln w="15875">
-            <a:solidFill>
-              <a:srgbClr val="C0392B"/>
-            </a:solidFill>
-          </a:ln>
-          <a:effectLst/>
-        </p:spPr>
-        <p:style>
-          <a:lnRef idx="1">
-            <a:schemeClr val="accent1"/>
-          </a:lnRef>
-          <a:fillRef idx="3">
-            <a:schemeClr val="accent1"/>
-          </a:fillRef>
-          <a:effectRef idx="2">
-            <a:schemeClr val="accent1"/>
-          </a:effectRef>
-          <a:fontRef idx="minor">
-            <a:schemeClr val="lt1"/>
-          </a:fontRef>
-        </p:style>
-        <p:txBody>
-          <a:bodyPr rtlCol="0" anchor="ctr"/>
-          <a:lstStyle/>
-          <a:p>
-            <a:pPr algn="ctr"/>
-          </a:p>
-        </p:txBody>
-      </p:sp>
-      <p:sp>
-        <p:nvSpPr>
-          <p:cNvPr id="12" name="TextBox 11"/>
-          <p:cNvSpPr txBox="1"/>
-          <p:nvPr/>
-        </p:nvSpPr>
-        <p:spPr>
-          <a:xfrm>
-            <a:off x="8860536" y="1572768"/>
-            <a:ext cx="2651760" cy="1280160"/>
-          </a:xfrm>
-          <a:prstGeom prst="rect">
-            <a:avLst/>
-          </a:prstGeom>
-          <a:noFill/>
-        </p:spPr>
-        <p:txBody>
-          <a:bodyPr wrap="square" anchor="ctr" lIns="0" rIns="0" tIns="0" bIns="0">
-            <a:spAutoFit/>
-          </a:bodyPr>
-          <a:lstStyle/>
-          <a:p>
-            <a:pPr algn="ctr">
-              <a:spcAft>
-                <a:spcPts val="200"/>
-              </a:spcAft>
-            </a:pPr>
-            <a:r>
-              <a:rPr sz="3400" b="1" i="0">
-                <a:solidFill>
-                  <a:srgbClr val="C0392B"/>
-                </a:solidFill>
-                <a:latin typeface="Georgia"/>
-              </a:rPr>
-              <a:t>88%</a:t>
-            </a:r>
-          </a:p>
-          <a:p>
-            <a:pPr algn="ctr">
-              <a:spcAft>
-                <a:spcPts val="200"/>
-              </a:spcAft>
-            </a:pPr>
-            <a:r>
-              <a:rPr sz="1200" b="0" i="0">
-                <a:solidFill>
-                  <a:srgbClr val="5A5A5A"/>
-                </a:solidFill>
-                <a:latin typeface="Calibri"/>
-              </a:rPr>
-              <a:t>Bloqueo injection</a:t>
+              <a:t>Evidencia de ejecución — seguridad y RAG</a:t>
             </a:r>
           </a:p>
         </p:txBody>
       </p:sp>
       <p:pic>
         <p:nvPicPr>
-          <p:cNvPr id="13" name="Picture 12" descr="01_precision_por_escenario.png"/>
+          <p:cNvPr id="5" name="Picture 4" descr="ev_03_seg_rag.png"/>
           <p:cNvPicPr>
             <a:picLocks noChangeAspect="1"/>
           </p:cNvPicPr>
@@ -8854,32 +9160,8 @@
         </p:blipFill>
         <p:spPr>
           <a:xfrm>
-            <a:off x="548640" y="3200400"/>
-            <a:ext cx="5486400" cy="2786063"/>
-          </a:xfrm>
-          <a:prstGeom prst="rect">
-            <a:avLst/>
-          </a:prstGeom>
-        </p:spPr>
-      </p:pic>
-      <p:pic>
-        <p:nvPicPr>
-          <p:cNvPr id="14" name="Picture 13" descr="02_latencia_por_escenario.png"/>
-          <p:cNvPicPr>
-            <a:picLocks noChangeAspect="1"/>
-          </p:cNvPicPr>
-          <p:nvPr/>
-        </p:nvPicPr>
-        <p:blipFill>
-          <a:blip r:embed="rId3"/>
-          <a:stretch>
-            <a:fillRect/>
-          </a:stretch>
-        </p:blipFill>
-        <p:spPr>
-          <a:xfrm>
-            <a:off x="6217920" y="3200400"/>
-            <a:ext cx="5486400" cy="2779858"/>
+            <a:off x="2249424" y="1463040"/>
+            <a:ext cx="7680960" cy="4607592"/>
           </a:xfrm>
           <a:prstGeom prst="rect">
             <a:avLst/>
@@ -8982,7 +9264,7 @@
                 </a:solidFill>
                 <a:latin typeface="Georgia"/>
               </a:rPr>
-              <a:t>7</a:t>
+              <a:t>5</a:t>
             </a:r>
           </a:p>
         </p:txBody>
@@ -9021,45 +9303,21 @@
                 </a:solidFill>
                 <a:latin typeface="Georgia"/>
               </a:rPr>
-              <a:t>Trazabilidad — hallazgos clave</a:t>
-            </a:r>
-          </a:p>
-        </p:txBody>
-      </p:sp>
-      <p:pic>
-        <p:nvPicPr>
-          <p:cNvPr id="5" name="Picture 4" descr="03_serie_temporal_incidente.png"/>
-          <p:cNvPicPr>
-            <a:picLocks noChangeAspect="1"/>
-          </p:cNvPicPr>
-          <p:nvPr/>
-        </p:nvPicPr>
-        <p:blipFill>
-          <a:blip r:embed="rId2"/>
-          <a:stretch>
-            <a:fillRect/>
-          </a:stretch>
-        </p:blipFill>
-        <p:spPr>
-          <a:xfrm>
-            <a:off x="6126480" y="1554480"/>
-            <a:ext cx="5669280" cy="2684207"/>
-          </a:xfrm>
-          <a:prstGeom prst="rect">
-            <a:avLst/>
-          </a:prstGeom>
-        </p:spPr>
-      </p:pic>
-      <p:sp>
-        <p:nvSpPr>
-          <p:cNvPr id="6" name="TextBox 5"/>
+              <a:t>Diseño LLM + RAG</a:t>
+            </a:r>
+          </a:p>
+        </p:txBody>
+      </p:sp>
+      <p:sp>
+        <p:nvSpPr>
+          <p:cNvPr id="5" name="TextBox 4"/>
           <p:cNvSpPr txBox="1"/>
           <p:nvPr/>
         </p:nvSpPr>
         <p:spPr>
           <a:xfrm>
-            <a:off x="548640" y="1645920"/>
-            <a:ext cx="5394960" cy="4572000"/>
+            <a:off x="548640" y="1554480"/>
+            <a:ext cx="5943600" cy="4114800"/>
           </a:xfrm>
           <a:prstGeom prst="rect">
             <a:avLst/>
@@ -9077,11 +9335,11 @@
                 <a:spcPct val="105000"/>
               </a:lnSpc>
               <a:spcAft>
-                <a:spcPts val="1300"/>
-              </a:spcAft>
-            </a:pPr>
-            <a:r>
-              <a:rPr sz="1550" b="1">
+                <a:spcPts val="1200"/>
+              </a:spcAft>
+            </a:pPr>
+            <a:r>
+              <a:rPr sz="1600" b="1">
                 <a:solidFill>
                   <a:srgbClr val="E8A33D"/>
                 </a:solidFill>
@@ -9090,22 +9348,22 @@
               <a:t>▪  </a:t>
             </a:r>
             <a:r>
-              <a:rPr b="1" sz="1550">
+              <a:rPr b="1" sz="1600">
                 <a:solidFill>
                   <a:srgbClr val="222B35"/>
                 </a:solidFill>
                 <a:latin typeface="Calibri"/>
               </a:rPr>
-              <a:t>Incidente detectado. </a:t>
-            </a:r>
-            <a:r>
-              <a:rPr sz="1550">
+              <a:t>Prompts. </a:t>
+            </a:r>
+            <a:r>
+              <a:rPr sz="1600">
                 <a:solidFill>
                   <a:srgbClr val="222B35"/>
                 </a:solidFill>
                 <a:latin typeface="Calibri"/>
               </a:rPr>
-              <a:t>2025-06-11, latencia y error con z≈3 (auto-detección).</a:t>
+              <a:t>System prompt con rol y reglas + few-shot + chain-of-thought.</a:t>
             </a:r>
           </a:p>
           <a:p>
@@ -9114,11 +9372,11 @@
                 <a:spcPct val="105000"/>
               </a:lnSpc>
               <a:spcAft>
-                <a:spcPts val="1300"/>
-              </a:spcAft>
-            </a:pPr>
-            <a:r>
-              <a:rPr sz="1550" b="1">
+                <a:spcPts val="1200"/>
+              </a:spcAft>
+            </a:pPr>
+            <a:r>
+              <a:rPr sz="1600" b="1">
                 <a:solidFill>
                   <a:srgbClr val="E8A33D"/>
                 </a:solidFill>
@@ -9127,22 +9385,22 @@
               <a:t>▪  </a:t>
             </a:r>
             <a:r>
-              <a:rPr b="1" sz="1550">
+              <a:rPr b="1" sz="1600">
                 <a:solidFill>
                   <a:srgbClr val="222B35"/>
                 </a:solidFill>
                 <a:latin typeface="Calibri"/>
               </a:rPr>
-              <a:t>Cuello de botella. </a:t>
-            </a:r>
-            <a:r>
-              <a:rPr sz="1550">
+              <a:t>RAG. </a:t>
+            </a:r>
+            <a:r>
+              <a:rPr sz="1600">
                 <a:solidFill>
                   <a:srgbClr val="222B35"/>
                 </a:solidFill>
                 <a:latin typeface="Calibri"/>
               </a:rPr>
-              <a:t>Orquestación multi-agente, p95 ≈ 21 s.</a:t>
+              <a:t>Chunking → TF-IDF → recuperación top-k para fundamentar respuestas.</a:t>
             </a:r>
           </a:p>
           <a:p>
@@ -9151,11 +9409,11 @@
                 <a:spcPct val="105000"/>
               </a:lnSpc>
               <a:spcAft>
-                <a:spcPts val="1300"/>
-              </a:spcAft>
-            </a:pPr>
-            <a:r>
-              <a:rPr sz="1550" b="1">
+                <a:spcPts val="1200"/>
+              </a:spcAft>
+            </a:pPr>
+            <a:r>
+              <a:rPr sz="1600" b="1">
                 <a:solidFill>
                   <a:srgbClr val="E8A33D"/>
                 </a:solidFill>
@@ -9164,22 +9422,22 @@
               <a:t>▪  </a:t>
             </a:r>
             <a:r>
-              <a:rPr b="1" sz="1550">
+              <a:rPr b="1" sz="1600">
                 <a:solidFill>
                   <a:srgbClr val="222B35"/>
                 </a:solidFill>
                 <a:latin typeface="Calibri"/>
               </a:rPr>
-              <a:t>Predictor de éxito. </a:t>
-            </a:r>
-            <a:r>
-              <a:rPr sz="1550">
+              <a:t>Fuentes internas. </a:t>
+            </a:r>
+            <a:r>
+              <a:rPr sz="1600">
                 <a:solidFill>
                   <a:srgbClr val="222B35"/>
                 </a:solidFill>
                 <a:latin typeface="Calibri"/>
               </a:rPr>
-              <a:t>Elegir la herramienta correcta: 95% vs 0%.</a:t>
+              <a:t>Productos y políticas del banco.</a:t>
             </a:r>
           </a:p>
           <a:p>
@@ -9188,11 +9446,11 @@
                 <a:spcPct val="105000"/>
               </a:lnSpc>
               <a:spcAft>
-                <a:spcPts val="1300"/>
-              </a:spcAft>
-            </a:pPr>
-            <a:r>
-              <a:rPr sz="1550" b="1">
+                <a:spcPts val="1200"/>
+              </a:spcAft>
+            </a:pPr>
+            <a:r>
+              <a:rPr sz="1600" b="1">
                 <a:solidFill>
                   <a:srgbClr val="E8A33D"/>
                 </a:solidFill>
@@ -9201,22 +9459,217 @@
               <a:t>▪  </a:t>
             </a:r>
             <a:r>
-              <a:rPr b="1" sz="1550">
+              <a:rPr b="1" sz="1600">
                 <a:solidFill>
                   <a:srgbClr val="222B35"/>
                 </a:solidFill>
                 <a:latin typeface="Calibri"/>
               </a:rPr>
-              <a:t>Ambigüedad. </a:t>
-            </a:r>
-            <a:r>
-              <a:rPr sz="1550">
+              <a:t>Fuentes externas. </a:t>
+            </a:r>
+            <a:r>
+              <a:rPr sz="1600">
                 <a:solidFill>
                   <a:srgbClr val="222B35"/>
                 </a:solidFill>
                 <a:latin typeface="Calibri"/>
               </a:rPr>
-              <a:t>Precisión cae 37 pp con entradas poco claras.</a:t>
+              <a:t>Normativa CMF, SERNAC y Ley 19.628.</a:t>
+            </a:r>
+          </a:p>
+        </p:txBody>
+      </p:sp>
+      <p:sp>
+        <p:nvSpPr>
+          <p:cNvPr id="6" name="Rounded Rectangle 5"/>
+          <p:cNvSpPr/>
+          <p:nvPr/>
+        </p:nvSpPr>
+        <p:spPr>
+          <a:xfrm>
+            <a:off x="6858000" y="1737360"/>
+            <a:ext cx="4754880" cy="3840480"/>
+          </a:xfrm>
+          <a:prstGeom prst="roundRect">
+            <a:avLst/>
+          </a:prstGeom>
+          <a:solidFill>
+            <a:srgbClr val="D6E4F0"/>
+          </a:solidFill>
+          <a:ln>
+            <a:noFill/>
+          </a:ln>
+          <a:effectLst/>
+        </p:spPr>
+        <p:style>
+          <a:lnRef idx="1">
+            <a:schemeClr val="accent1"/>
+          </a:lnRef>
+          <a:fillRef idx="3">
+            <a:schemeClr val="accent1"/>
+          </a:fillRef>
+          <a:effectRef idx="2">
+            <a:schemeClr val="accent1"/>
+          </a:effectRef>
+          <a:fontRef idx="minor">
+            <a:schemeClr val="lt1"/>
+          </a:fontRef>
+        </p:style>
+        <p:txBody>
+          <a:bodyPr rtlCol="0" anchor="ctr"/>
+          <a:lstStyle/>
+          <a:p>
+            <a:pPr algn="ctr"/>
+          </a:p>
+        </p:txBody>
+      </p:sp>
+      <p:sp>
+        <p:nvSpPr>
+          <p:cNvPr id="7" name="TextBox 6"/>
+          <p:cNvSpPr txBox="1"/>
+          <p:nvPr/>
+        </p:nvSpPr>
+        <p:spPr>
+          <a:xfrm>
+            <a:off x="7132320" y="1965960"/>
+            <a:ext cx="4206240" cy="3474720"/>
+          </a:xfrm>
+          <a:prstGeom prst="rect">
+            <a:avLst/>
+          </a:prstGeom>
+          <a:noFill/>
+        </p:spPr>
+        <p:txBody>
+          <a:bodyPr wrap="square" anchor="t" lIns="0" rIns="0" tIns="0" bIns="0">
+            <a:spAutoFit/>
+          </a:bodyPr>
+          <a:lstStyle/>
+          <a:p>
+            <a:pPr algn="l">
+              <a:spcAft>
+                <a:spcPts val="200"/>
+              </a:spcAft>
+            </a:pPr>
+            <a:r>
+              <a:rPr sz="1600" b="1" i="0">
+                <a:solidFill>
+                  <a:srgbClr val="1F4E79"/>
+                </a:solidFill>
+                <a:latin typeface="Georgia"/>
+              </a:rPr>
+              <a:t>Recuperación combinada</a:t>
+            </a:r>
+          </a:p>
+          <a:p>
+            <a:pPr algn="l">
+              <a:spcAft>
+                <a:spcPts val="200"/>
+              </a:spcAft>
+            </a:pPr>
+            <a:r>
+              <a:rPr sz="1200" b="0" i="1">
+                <a:solidFill>
+                  <a:srgbClr val="5A5A5A"/>
+                </a:solidFill>
+                <a:latin typeface="Calibri"/>
+              </a:rPr>
+              <a:t>Consulta: tasa de crédito + deber de información</a:t>
+            </a:r>
+          </a:p>
+          <a:p>
+            <a:pPr algn="l">
+              <a:spcAft>
+                <a:spcPts val="200"/>
+              </a:spcAft>
+            </a:pPr>
+            <a:r>
+              <a:rPr sz="600" b="0" i="0">
+                <a:solidFill>
+                  <a:srgbClr val="5A5A5A"/>
+                </a:solidFill>
+                <a:latin typeface="Calibri"/>
+              </a:rPr>
+              <a:t/>
+            </a:r>
+          </a:p>
+          <a:p>
+            <a:pPr algn="l">
+              <a:spcAft>
+                <a:spcPts val="200"/>
+              </a:spcAft>
+            </a:pPr>
+            <a:r>
+              <a:rPr sz="1300" b="0" i="0">
+                <a:solidFill>
+                  <a:srgbClr val="222B35"/>
+                </a:solidFill>
+                <a:latin typeface="Calibri"/>
+              </a:rPr>
+              <a:t>● interna — Catálogo de productos</a:t>
+            </a:r>
+          </a:p>
+          <a:p>
+            <a:pPr algn="l">
+              <a:spcAft>
+                <a:spcPts val="200"/>
+              </a:spcAft>
+            </a:pPr>
+            <a:r>
+              <a:rPr sz="1300" b="0" i="0">
+                <a:solidFill>
+                  <a:srgbClr val="222B35"/>
+                </a:solidFill>
+                <a:latin typeface="Calibri"/>
+              </a:rPr>
+              <a:t>● externa — CMF (información al cliente)</a:t>
+            </a:r>
+          </a:p>
+          <a:p>
+            <a:pPr algn="l">
+              <a:spcAft>
+                <a:spcPts val="200"/>
+              </a:spcAft>
+            </a:pPr>
+            <a:r>
+              <a:rPr sz="1300" b="0" i="0">
+                <a:solidFill>
+                  <a:srgbClr val="222B35"/>
+                </a:solidFill>
+                <a:latin typeface="Calibri"/>
+              </a:rPr>
+              <a:t>● interna — Política de crédito</a:t>
+            </a:r>
+          </a:p>
+          <a:p>
+            <a:pPr algn="l">
+              <a:spcAft>
+                <a:spcPts val="200"/>
+              </a:spcAft>
+            </a:pPr>
+            <a:r>
+              <a:rPr sz="600" b="0" i="0">
+                <a:solidFill>
+                  <a:srgbClr val="5A5A5A"/>
+                </a:solidFill>
+                <a:latin typeface="Calibri"/>
+              </a:rPr>
+              <a:t/>
+            </a:r>
+          </a:p>
+          <a:p>
+            <a:pPr algn="l">
+              <a:spcAft>
+                <a:spcPts val="200"/>
+              </a:spcAft>
+            </a:pPr>
+            <a:r>
+              <a:rPr sz="1200" b="1" i="0">
+                <a:solidFill>
+                  <a:srgbClr val="2E7D32"/>
+                </a:solidFill>
+                <a:latin typeface="Calibri"/>
+              </a:rPr>
+              <a:t>→ combina ambos orígenes en una sola respuesta</a:t>
             </a:r>
           </a:p>
         </p:txBody>
@@ -9317,7 +9770,7 @@
                 </a:solidFill>
                 <a:latin typeface="Georgia"/>
               </a:rPr>
-              <a:t>8</a:t>
+              <a:t>6</a:t>
             </a:r>
           </a:p>
         </p:txBody>
@@ -9356,238 +9809,30 @@
                 </a:solidFill>
                 <a:latin typeface="Georgia"/>
               </a:rPr>
-              <a:t>Seguridad y uso responsable</a:t>
-            </a:r>
-          </a:p>
-        </p:txBody>
-      </p:sp>
-      <p:sp>
-        <p:nvSpPr>
-          <p:cNvPr id="5" name="TextBox 4"/>
-          <p:cNvSpPr txBox="1"/>
-          <p:nvPr/>
-        </p:nvSpPr>
-        <p:spPr>
-          <a:xfrm>
-            <a:off x="548640" y="1600200"/>
-            <a:ext cx="5852160" cy="4572000"/>
-          </a:xfrm>
-          <a:prstGeom prst="rect">
-            <a:avLst/>
-          </a:prstGeom>
-          <a:noFill/>
-        </p:spPr>
-        <p:txBody>
-          <a:bodyPr wrap="square" lIns="0" rIns="0" tIns="0" bIns="0">
-            <a:spAutoFit/>
-          </a:bodyPr>
-          <a:lstStyle/>
-          <a:p>
-            <a:pPr>
-              <a:lnSpc>
-                <a:spcPct val="105000"/>
-              </a:lnSpc>
-              <a:spcAft>
-                <a:spcPts val="1100"/>
-              </a:spcAft>
-            </a:pPr>
-            <a:r>
-              <a:rPr sz="1550" b="1">
-                <a:solidFill>
-                  <a:srgbClr val="E8A33D"/>
-                </a:solidFill>
-                <a:latin typeface="Calibri"/>
-              </a:rPr>
-              <a:t>▪  </a:t>
-            </a:r>
-            <a:r>
-              <a:rPr b="1" sz="1550">
-                <a:solidFill>
-                  <a:srgbClr val="222B35"/>
-                </a:solidFill>
-                <a:latin typeface="Calibri"/>
-              </a:rPr>
-              <a:t>Privacidad por diseño. </a:t>
-            </a:r>
-            <a:r>
-              <a:rPr sz="1550">
-                <a:solidFill>
-                  <a:srgbClr val="222B35"/>
-                </a:solidFill>
-                <a:latin typeface="Calibri"/>
-              </a:rPr>
-              <a:t>Enmascaramiento de PII (RUT, tarjeta) en logs y prompts.</a:t>
-            </a:r>
-          </a:p>
-          <a:p>
-            <a:pPr>
-              <a:lnSpc>
-                <a:spcPct val="105000"/>
-              </a:lnSpc>
-              <a:spcAft>
-                <a:spcPts val="1100"/>
-              </a:spcAft>
-            </a:pPr>
-            <a:r>
-              <a:rPr sz="1550" b="1">
-                <a:solidFill>
-                  <a:srgbClr val="E8A33D"/>
-                </a:solidFill>
-                <a:latin typeface="Calibri"/>
-              </a:rPr>
-              <a:t>▪  </a:t>
-            </a:r>
-            <a:r>
-              <a:rPr b="1" sz="1550">
-                <a:solidFill>
-                  <a:srgbClr val="222B35"/>
-                </a:solidFill>
-                <a:latin typeface="Calibri"/>
-              </a:rPr>
-              <a:t>Anti prompt-injection. </a:t>
-            </a:r>
-            <a:r>
-              <a:rPr sz="1550">
-                <a:solidFill>
-                  <a:srgbClr val="222B35"/>
-                </a:solidFill>
-                <a:latin typeface="Calibri"/>
-              </a:rPr>
-              <a:t>Bloqueo de manipulación del prompt (OWASP LLM01).</a:t>
-            </a:r>
-          </a:p>
-          <a:p>
-            <a:pPr>
-              <a:lnSpc>
-                <a:spcPct val="105000"/>
-              </a:lnSpc>
-              <a:spcAft>
-                <a:spcPts val="1100"/>
-              </a:spcAft>
-            </a:pPr>
-            <a:r>
-              <a:rPr sz="1550" b="1">
-                <a:solidFill>
-                  <a:srgbClr val="E8A33D"/>
-                </a:solidFill>
-                <a:latin typeface="Calibri"/>
-              </a:rPr>
-              <a:t>▪  </a:t>
-            </a:r>
-            <a:r>
-              <a:rPr b="1" sz="1550">
-                <a:solidFill>
-                  <a:srgbClr val="222B35"/>
-                </a:solidFill>
-                <a:latin typeface="Calibri"/>
-              </a:rPr>
-              <a:t>Rate-limit + validación. </a:t>
-            </a:r>
-            <a:r>
-              <a:rPr sz="1550">
-                <a:solidFill>
-                  <a:srgbClr val="222B35"/>
-                </a:solidFill>
-                <a:latin typeface="Calibri"/>
-              </a:rPr>
-              <a:t>Control de abuso y saneamiento de entrada.</a:t>
-            </a:r>
-          </a:p>
-          <a:p>
-            <a:pPr>
-              <a:lnSpc>
-                <a:spcPct val="105000"/>
-              </a:lnSpc>
-              <a:spcAft>
-                <a:spcPts val="1100"/>
-              </a:spcAft>
-            </a:pPr>
-            <a:r>
-              <a:rPr sz="1550" b="1">
-                <a:solidFill>
-                  <a:srgbClr val="E8A33D"/>
-                </a:solidFill>
-                <a:latin typeface="Calibri"/>
-              </a:rPr>
-              <a:t>▪  </a:t>
-            </a:r>
-            <a:r>
-              <a:rPr b="1" sz="1550">
-                <a:solidFill>
-                  <a:srgbClr val="222B35"/>
-                </a:solidFill>
-                <a:latin typeface="Calibri"/>
-              </a:rPr>
-              <a:t>Auditoría con hash. </a:t>
-            </a:r>
-            <a:r>
-              <a:rPr sz="1550">
-                <a:solidFill>
-                  <a:srgbClr val="222B35"/>
-                </a:solidFill>
-                <a:latin typeface="Calibri"/>
-              </a:rPr>
-              <a:t>Bitácora con integridad (no-repudio).</a:t>
-            </a:r>
-          </a:p>
-          <a:p>
-            <a:pPr>
-              <a:lnSpc>
-                <a:spcPct val="105000"/>
-              </a:lnSpc>
-              <a:spcAft>
-                <a:spcPts val="1100"/>
-              </a:spcAft>
-            </a:pPr>
-            <a:r>
-              <a:rPr sz="1550" b="1">
-                <a:solidFill>
-                  <a:srgbClr val="E8A33D"/>
-                </a:solidFill>
-                <a:latin typeface="Calibri"/>
-              </a:rPr>
-              <a:t>▪  </a:t>
-            </a:r>
-            <a:r>
-              <a:rPr b="1" sz="1550">
-                <a:solidFill>
-                  <a:srgbClr val="222B35"/>
-                </a:solidFill>
-                <a:latin typeface="Calibri"/>
-              </a:rPr>
-              <a:t>Confirmación humana. </a:t>
-            </a:r>
-            <a:r>
-              <a:rPr sz="1550">
-                <a:solidFill>
-                  <a:srgbClr val="222B35"/>
-                </a:solidFill>
-                <a:latin typeface="Calibri"/>
-              </a:rPr>
-              <a:t>Toda transferencia se valida explícitamente.</a:t>
-            </a:r>
-          </a:p>
-        </p:txBody>
-      </p:sp>
-      <p:sp>
-        <p:nvSpPr>
-          <p:cNvPr id="6" name="Rounded Rectangle 5"/>
+              <a:t>Observabilidad — resultados</a:t>
+            </a:r>
+          </a:p>
+        </p:txBody>
+      </p:sp>
+      <p:sp>
+        <p:nvSpPr>
+          <p:cNvPr id="5" name="Rounded Rectangle 4"/>
           <p:cNvSpPr/>
           <p:nvPr/>
         </p:nvSpPr>
         <p:spPr>
           <a:xfrm>
-            <a:off x="6858000" y="1737360"/>
-            <a:ext cx="4754880" cy="3749039"/>
+            <a:off x="548640" y="1508760"/>
+            <a:ext cx="2651760" cy="1371600"/>
           </a:xfrm>
           <a:prstGeom prst="roundRect">
             <a:avLst/>
           </a:prstGeom>
-          <a:solidFill>
-            <a:srgbClr val="0F2540"/>
-          </a:solidFill>
-          <a:ln>
-            <a:noFill/>
+          <a:noFill/>
+          <a:ln w="15875">
+            <a:solidFill>
+              <a:srgbClr val="2E7D32"/>
+            </a:solidFill>
           </a:ln>
           <a:effectLst/>
         </p:spPr>
@@ -9615,14 +9860,14 @@
       </p:sp>
       <p:sp>
         <p:nvSpPr>
-          <p:cNvPr id="7" name="TextBox 6"/>
+          <p:cNvPr id="6" name="TextBox 5"/>
           <p:cNvSpPr txBox="1"/>
           <p:nvPr/>
         </p:nvSpPr>
         <p:spPr>
           <a:xfrm>
-            <a:off x="7178040" y="2011680"/>
-            <a:ext cx="4206240" cy="3291840"/>
+            <a:off x="548640" y="1572768"/>
+            <a:ext cx="2651760" cy="1280160"/>
           </a:xfrm>
           <a:prstGeom prst="rect">
             <a:avLst/>
@@ -9630,140 +9875,389 @@
           <a:noFill/>
         </p:spPr>
         <p:txBody>
-          <a:bodyPr wrap="square" anchor="t" lIns="0" rIns="0" tIns="0" bIns="0">
+          <a:bodyPr wrap="square" anchor="ctr" lIns="0" rIns="0" tIns="0" bIns="0">
             <a:spAutoFit/>
           </a:bodyPr>
           <a:lstStyle/>
           <a:p>
-            <a:pPr algn="l">
+            <a:pPr algn="ctr">
               <a:spcAft>
                 <a:spcPts val="200"/>
               </a:spcAft>
             </a:pPr>
             <a:r>
-              <a:rPr sz="1600" b="1" i="0">
+              <a:rPr sz="3400" b="1" i="0">
+                <a:solidFill>
+                  <a:srgbClr val="2E7D32"/>
+                </a:solidFill>
+                <a:latin typeface="Georgia"/>
+              </a:rPr>
+              <a:t>85%</a:t>
+            </a:r>
+          </a:p>
+          <a:p>
+            <a:pPr algn="ctr">
+              <a:spcAft>
+                <a:spcPts val="200"/>
+              </a:spcAft>
+            </a:pPr>
+            <a:r>
+              <a:rPr sz="1200" b="0" i="0">
+                <a:solidFill>
+                  <a:srgbClr val="5A5A5A"/>
+                </a:solidFill>
+                <a:latin typeface="Calibri"/>
+              </a:rPr>
+              <a:t>Precisión</a:t>
+            </a:r>
+          </a:p>
+        </p:txBody>
+      </p:sp>
+      <p:sp>
+        <p:nvSpPr>
+          <p:cNvPr id="7" name="Rounded Rectangle 6"/>
+          <p:cNvSpPr/>
+          <p:nvPr/>
+        </p:nvSpPr>
+        <p:spPr>
+          <a:xfrm>
+            <a:off x="3319272" y="1508760"/>
+            <a:ext cx="2651760" cy="1371600"/>
+          </a:xfrm>
+          <a:prstGeom prst="roundRect">
+            <a:avLst/>
+          </a:prstGeom>
+          <a:noFill/>
+          <a:ln w="15875">
+            <a:solidFill>
+              <a:srgbClr val="E8A33D"/>
+            </a:solidFill>
+          </a:ln>
+          <a:effectLst/>
+        </p:spPr>
+        <p:style>
+          <a:lnRef idx="1">
+            <a:schemeClr val="accent1"/>
+          </a:lnRef>
+          <a:fillRef idx="3">
+            <a:schemeClr val="accent1"/>
+          </a:fillRef>
+          <a:effectRef idx="2">
+            <a:schemeClr val="accent1"/>
+          </a:effectRef>
+          <a:fontRef idx="minor">
+            <a:schemeClr val="lt1"/>
+          </a:fontRef>
+        </p:style>
+        <p:txBody>
+          <a:bodyPr rtlCol="0" anchor="ctr"/>
+          <a:lstStyle/>
+          <a:p>
+            <a:pPr algn="ctr"/>
+          </a:p>
+        </p:txBody>
+      </p:sp>
+      <p:sp>
+        <p:nvSpPr>
+          <p:cNvPr id="8" name="TextBox 7"/>
+          <p:cNvSpPr txBox="1"/>
+          <p:nvPr/>
+        </p:nvSpPr>
+        <p:spPr>
+          <a:xfrm>
+            <a:off x="3319272" y="1572768"/>
+            <a:ext cx="2651760" cy="1280160"/>
+          </a:xfrm>
+          <a:prstGeom prst="rect">
+            <a:avLst/>
+          </a:prstGeom>
+          <a:noFill/>
+        </p:spPr>
+        <p:txBody>
+          <a:bodyPr wrap="square" anchor="ctr" lIns="0" rIns="0" tIns="0" bIns="0">
+            <a:spAutoFit/>
+          </a:bodyPr>
+          <a:lstStyle/>
+          <a:p>
+            <a:pPr algn="ctr">
+              <a:spcAft>
+                <a:spcPts val="200"/>
+              </a:spcAft>
+            </a:pPr>
+            <a:r>
+              <a:rPr sz="3400" b="1" i="0">
                 <a:solidFill>
                   <a:srgbClr val="E8A33D"/>
                 </a:solidFill>
                 <a:latin typeface="Georgia"/>
               </a:rPr>
-              <a:t>Marco normativo</a:t>
-            </a:r>
-          </a:p>
-          <a:p>
-            <a:pPr algn="l">
+              <a:t>6.9%</a:t>
+            </a:r>
+          </a:p>
+          <a:p>
+            <a:pPr algn="ctr">
               <a:spcAft>
                 <a:spcPts val="200"/>
               </a:spcAft>
             </a:pPr>
             <a:r>
-              <a:rPr sz="600" b="0" i="0">
-                <a:solidFill>
-                  <a:srgbClr val="FFFFFF"/>
-                </a:solidFill>
-                <a:latin typeface="Calibri"/>
-              </a:rPr>
-              <a:t/>
-            </a:r>
-          </a:p>
-          <a:p>
-            <a:pPr algn="l">
+              <a:rPr sz="1200" b="0" i="0">
+                <a:solidFill>
+                  <a:srgbClr val="5A5A5A"/>
+                </a:solidFill>
+                <a:latin typeface="Calibri"/>
+              </a:rPr>
+              <a:t>Tasa de error</a:t>
+            </a:r>
+          </a:p>
+        </p:txBody>
+      </p:sp>
+      <p:sp>
+        <p:nvSpPr>
+          <p:cNvPr id="9" name="Rounded Rectangle 8"/>
+          <p:cNvSpPr/>
+          <p:nvPr/>
+        </p:nvSpPr>
+        <p:spPr>
+          <a:xfrm>
+            <a:off x="6089904" y="1508760"/>
+            <a:ext cx="2651760" cy="1371600"/>
+          </a:xfrm>
+          <a:prstGeom prst="roundRect">
+            <a:avLst/>
+          </a:prstGeom>
+          <a:noFill/>
+          <a:ln w="15875">
+            <a:solidFill>
+              <a:srgbClr val="1F4E79"/>
+            </a:solidFill>
+          </a:ln>
+          <a:effectLst/>
+        </p:spPr>
+        <p:style>
+          <a:lnRef idx="1">
+            <a:schemeClr val="accent1"/>
+          </a:lnRef>
+          <a:fillRef idx="3">
+            <a:schemeClr val="accent1"/>
+          </a:fillRef>
+          <a:effectRef idx="2">
+            <a:schemeClr val="accent1"/>
+          </a:effectRef>
+          <a:fontRef idx="minor">
+            <a:schemeClr val="lt1"/>
+          </a:fontRef>
+        </p:style>
+        <p:txBody>
+          <a:bodyPr rtlCol="0" anchor="ctr"/>
+          <a:lstStyle/>
+          <a:p>
+            <a:pPr algn="ctr"/>
+          </a:p>
+        </p:txBody>
+      </p:sp>
+      <p:sp>
+        <p:nvSpPr>
+          <p:cNvPr id="10" name="TextBox 9"/>
+          <p:cNvSpPr txBox="1"/>
+          <p:nvPr/>
+        </p:nvSpPr>
+        <p:spPr>
+          <a:xfrm>
+            <a:off x="6089904" y="1572768"/>
+            <a:ext cx="2651760" cy="1280160"/>
+          </a:xfrm>
+          <a:prstGeom prst="rect">
+            <a:avLst/>
+          </a:prstGeom>
+          <a:noFill/>
+        </p:spPr>
+        <p:txBody>
+          <a:bodyPr wrap="square" anchor="ctr" lIns="0" rIns="0" tIns="0" bIns="0">
+            <a:spAutoFit/>
+          </a:bodyPr>
+          <a:lstStyle/>
+          <a:p>
+            <a:pPr algn="ctr">
               <a:spcAft>
                 <a:spcPts val="200"/>
               </a:spcAft>
             </a:pPr>
             <a:r>
-              <a:rPr sz="1400" b="0" i="0">
-                <a:solidFill>
-                  <a:srgbClr val="FFFFFF"/>
-                </a:solidFill>
-                <a:latin typeface="Calibri"/>
-              </a:rPr>
-              <a:t>Ley 19.628 — datos personales</a:t>
-            </a:r>
-          </a:p>
-          <a:p>
-            <a:pPr algn="l">
+              <a:rPr sz="3400" b="1" i="0">
+                <a:solidFill>
+                  <a:srgbClr val="1F4E79"/>
+                </a:solidFill>
+                <a:latin typeface="Georgia"/>
+              </a:rPr>
+              <a:t>8.3s</a:t>
+            </a:r>
+          </a:p>
+          <a:p>
+            <a:pPr algn="ctr">
               <a:spcAft>
                 <a:spcPts val="200"/>
               </a:spcAft>
             </a:pPr>
             <a:r>
-              <a:rPr sz="1400" b="0" i="0">
-                <a:solidFill>
-                  <a:srgbClr val="FFFFFF"/>
-                </a:solidFill>
-                <a:latin typeface="Calibri"/>
-              </a:rPr>
-              <a:t>Normativa CMF — ciberseguridad</a:t>
-            </a:r>
-          </a:p>
-          <a:p>
-            <a:pPr algn="l">
+              <a:rPr sz="1200" b="0" i="0">
+                <a:solidFill>
+                  <a:srgbClr val="5A5A5A"/>
+                </a:solidFill>
+                <a:latin typeface="Calibri"/>
+              </a:rPr>
+              <a:t>Latencia p95</a:t>
+            </a:r>
+          </a:p>
+        </p:txBody>
+      </p:sp>
+      <p:sp>
+        <p:nvSpPr>
+          <p:cNvPr id="11" name="Rounded Rectangle 10"/>
+          <p:cNvSpPr/>
+          <p:nvPr/>
+        </p:nvSpPr>
+        <p:spPr>
+          <a:xfrm>
+            <a:off x="8860536" y="1508760"/>
+            <a:ext cx="2651760" cy="1371600"/>
+          </a:xfrm>
+          <a:prstGeom prst="roundRect">
+            <a:avLst/>
+          </a:prstGeom>
+          <a:noFill/>
+          <a:ln w="15875">
+            <a:solidFill>
+              <a:srgbClr val="C0392B"/>
+            </a:solidFill>
+          </a:ln>
+          <a:effectLst/>
+        </p:spPr>
+        <p:style>
+          <a:lnRef idx="1">
+            <a:schemeClr val="accent1"/>
+          </a:lnRef>
+          <a:fillRef idx="3">
+            <a:schemeClr val="accent1"/>
+          </a:fillRef>
+          <a:effectRef idx="2">
+            <a:schemeClr val="accent1"/>
+          </a:effectRef>
+          <a:fontRef idx="minor">
+            <a:schemeClr val="lt1"/>
+          </a:fontRef>
+        </p:style>
+        <p:txBody>
+          <a:bodyPr rtlCol="0" anchor="ctr"/>
+          <a:lstStyle/>
+          <a:p>
+            <a:pPr algn="ctr"/>
+          </a:p>
+        </p:txBody>
+      </p:sp>
+      <p:sp>
+        <p:nvSpPr>
+          <p:cNvPr id="12" name="TextBox 11"/>
+          <p:cNvSpPr txBox="1"/>
+          <p:nvPr/>
+        </p:nvSpPr>
+        <p:spPr>
+          <a:xfrm>
+            <a:off x="8860536" y="1572768"/>
+            <a:ext cx="2651760" cy="1280160"/>
+          </a:xfrm>
+          <a:prstGeom prst="rect">
+            <a:avLst/>
+          </a:prstGeom>
+          <a:noFill/>
+        </p:spPr>
+        <p:txBody>
+          <a:bodyPr wrap="square" anchor="ctr" lIns="0" rIns="0" tIns="0" bIns="0">
+            <a:spAutoFit/>
+          </a:bodyPr>
+          <a:lstStyle/>
+          <a:p>
+            <a:pPr algn="ctr">
               <a:spcAft>
                 <a:spcPts val="200"/>
               </a:spcAft>
             </a:pPr>
             <a:r>
-              <a:rPr sz="1400" b="0" i="0">
-                <a:solidFill>
-                  <a:srgbClr val="FFFFFF"/>
-                </a:solidFill>
-                <a:latin typeface="Calibri"/>
-              </a:rPr>
-              <a:t>OWASP Top 10 for LLM</a:t>
-            </a:r>
-          </a:p>
-          <a:p>
-            <a:pPr algn="l">
+              <a:rPr sz="3400" b="1" i="0">
+                <a:solidFill>
+                  <a:srgbClr val="C0392B"/>
+                </a:solidFill>
+                <a:latin typeface="Georgia"/>
+              </a:rPr>
+              <a:t>88%</a:t>
+            </a:r>
+          </a:p>
+          <a:p>
+            <a:pPr algn="ctr">
               <a:spcAft>
                 <a:spcPts val="200"/>
               </a:spcAft>
             </a:pPr>
             <a:r>
-              <a:rPr sz="800" b="0" i="0">
-                <a:solidFill>
-                  <a:srgbClr val="FFFFFF"/>
-                </a:solidFill>
-                <a:latin typeface="Calibri"/>
-              </a:rPr>
-              <a:t/>
-            </a:r>
-          </a:p>
-          <a:p>
-            <a:pPr algn="l">
-              <a:spcAft>
-                <a:spcPts val="200"/>
-              </a:spcAft>
-            </a:pPr>
-            <a:r>
-              <a:rPr sz="1300" b="0" i="1">
-                <a:solidFill>
-                  <a:srgbClr val="D6E4F0"/>
-                </a:solidFill>
-                <a:latin typeface="Calibri"/>
-              </a:rPr>
-              <a:t>Ética: transparencia, no maleficencia,</a:t>
-            </a:r>
-          </a:p>
-          <a:p>
-            <a:pPr algn="l">
-              <a:spcAft>
-                <a:spcPts val="200"/>
-              </a:spcAft>
-            </a:pPr>
-            <a:r>
-              <a:rPr sz="1300" b="0" i="1">
-                <a:solidFill>
-                  <a:srgbClr val="D6E4F0"/>
-                </a:solidFill>
-                <a:latin typeface="Calibri"/>
-              </a:rPr>
-              <a:t>equidad y supervisión humana.</a:t>
-            </a:r>
-          </a:p>
-        </p:txBody>
-      </p:sp>
+              <a:rPr sz="1200" b="0" i="0">
+                <a:solidFill>
+                  <a:srgbClr val="5A5A5A"/>
+                </a:solidFill>
+                <a:latin typeface="Calibri"/>
+              </a:rPr>
+              <a:t>Bloqueo injection</a:t>
+            </a:r>
+          </a:p>
+        </p:txBody>
+      </p:sp>
+      <p:pic>
+        <p:nvPicPr>
+          <p:cNvPr id="13" name="Picture 12" descr="01_precision_por_escenario.png"/>
+          <p:cNvPicPr>
+            <a:picLocks noChangeAspect="1"/>
+          </p:cNvPicPr>
+          <p:nvPr/>
+        </p:nvPicPr>
+        <p:blipFill>
+          <a:blip r:embed="rId2"/>
+          <a:stretch>
+            <a:fillRect/>
+          </a:stretch>
+        </p:blipFill>
+        <p:spPr>
+          <a:xfrm>
+            <a:off x="548640" y="3200400"/>
+            <a:ext cx="5486400" cy="2786063"/>
+          </a:xfrm>
+          <a:prstGeom prst="rect">
+            <a:avLst/>
+          </a:prstGeom>
+        </p:spPr>
+      </p:pic>
+      <p:pic>
+        <p:nvPicPr>
+          <p:cNvPr id="14" name="Picture 13" descr="02_latencia_por_escenario.png"/>
+          <p:cNvPicPr>
+            <a:picLocks noChangeAspect="1"/>
+          </p:cNvPicPr>
+          <p:nvPr/>
+        </p:nvPicPr>
+        <p:blipFill>
+          <a:blip r:embed="rId3"/>
+          <a:stretch>
+            <a:fillRect/>
+          </a:stretch>
+        </p:blipFill>
+        <p:spPr>
+          <a:xfrm>
+            <a:off x="6217920" y="3200400"/>
+            <a:ext cx="5486400" cy="2779858"/>
+          </a:xfrm>
+          <a:prstGeom prst="rect">
+            <a:avLst/>
+          </a:prstGeom>
+        </p:spPr>
+      </p:pic>
     </p:spTree>
   </p:cSld>
   <p:clrMapOvr>

</xml_diff>